<commit_message>
Add basic CRAFT starter prompts slide to EGR 440 deck
Co-Authored-By: Claude Opus 5.5 <noreply@anthropic.com>
Claude-Session: https://claude.ai/code/session_016nqxio3FFGLZJDKc7yTVy5
</commit_message>
<xml_diff>
--- a/slides/EGR_440_Scalable_Innovation.pptx
+++ b/slides/EGR_440_Scalable_Innovation.pptx
@@ -12,9 +12,10 @@
     <p:sldId id="260" r:id="rId6"/>
     <p:sldId id="261" r:id="rId7"/>
     <p:sldId id="262" r:id="rId8"/>
+    <p:sldId id="263" r:id="rId9"/>
   </p:sldIdLst>
   <p:notesMasterIdLst>
-    <p:notesMasterId r:id="rId9"/>
+    <p:notesMasterId r:id="rId10"/>
   </p:notesMasterIdLst>
   <p:sldSz cx="12192000" cy="6858000"/>
   <p:notesSz cx="6858000" cy="12192000"/>
@@ -1060,6 +1061,94 @@
             <a:fld id="{F7021451-1387-4CA6-816F-3879F97B5CBC}" type="slidenum">
               <a:rPr lang="en-US"/>
               <a:t>7</a:t>
+            </a:fld>
+            <a:endParaRPr lang="en-US"/>
+          </a:p>
+        </p:txBody>
+      </p:sp>
+    </p:spTree>
+    <p:extLst>
+      <p:ext uri="{BB962C8B-B14F-4D97-AF65-F5344CB8AC3E}">
+        <p14:creationId xmlns:p14="http://schemas.microsoft.com/office/powerpoint/2010/main" val="1024086991"/>
+      </p:ext>
+    </p:extLst>
+  </p:cSld>
+  <p:clrMapOvr>
+    <a:masterClrMapping/>
+  </p:clrMapOvr>
+</p:notes>
+</file>
+
+<file path=ppt/notesSlides/notesSlide8.xml><?xml version="1.0" encoding="utf-8"?>
+<p:notes xmlns:a="http://schemas.openxmlformats.org/drawingml/2006/main" xmlns:r="http://schemas.openxmlformats.org/officeDocument/2006/relationships" xmlns:p="http://schemas.openxmlformats.org/presentationml/2006/main">
+  <p:cSld>
+    <p:spTree>
+      <p:nvGrpSpPr>
+        <p:cNvPr id="1" name=""/>
+        <p:cNvGrpSpPr/>
+        <p:nvPr/>
+      </p:nvGrpSpPr>
+      <p:grpSpPr>
+        <a:xfrm>
+          <a:off x="0" y="0"/>
+          <a:ext cx="0" cy="0"/>
+          <a:chOff x="0" y="0"/>
+          <a:chExt cx="0" cy="0"/>
+        </a:xfrm>
+      </p:grpSpPr>
+      <p:sp>
+        <p:nvSpPr>
+          <p:cNvPr id="2" name="Slide Image Placeholder 1"/>
+          <p:cNvSpPr>
+            <a:spLocks noGrp="1" noRot="1" noChangeAspect="1"/>
+          </p:cNvSpPr>
+          <p:nvPr>
+            <p:ph type="sldImg"/>
+          </p:nvPr>
+        </p:nvSpPr>
+        <p:spPr/>
+      </p:sp>
+      <p:sp>
+        <p:nvSpPr>
+          <p:cNvPr id="3" name="Notes Placeholder 2"/>
+          <p:cNvSpPr>
+            <a:spLocks noGrp="1"/>
+          </p:cNvSpPr>
+          <p:nvPr>
+            <p:ph type="body" idx="1"/>
+          </p:nvPr>
+        </p:nvSpPr>
+        <p:spPr/>
+        <p:txBody>
+          <a:bodyPr/>
+          <a:lstStyle/>
+          <a:p>
+            <a:r>
+              <a:rPr lang="en-US" dirty="0"/>
+              <a:t/>
+            </a:r>
+            <a:endParaRPr lang="en-US" dirty="0"/>
+          </a:p>
+        </p:txBody>
+      </p:sp>
+      <p:sp>
+        <p:nvSpPr>
+          <p:cNvPr id="4" name="Slide Number Placeholder 3"/>
+          <p:cNvSpPr>
+            <a:spLocks noGrp="1"/>
+          </p:cNvSpPr>
+          <p:nvPr>
+            <p:ph type="sldNum" sz="quarter" idx="10"/>
+          </p:nvPr>
+        </p:nvSpPr>
+        <p:spPr/>
+        <p:txBody>
+          <a:bodyPr/>
+          <a:lstStyle/>
+          <a:p>
+            <a:fld id="{F7021451-1387-4CA6-816F-3879F97B5CBC}" type="slidenum">
+              <a:rPr lang="en-US"/>
+              <a:t>8</a:t>
             </a:fld>
             <a:endParaRPr lang="en-US"/>
           </a:p>
@@ -4474,7 +4563,7 @@
                 <a:ea typeface="Calibri" pitchFamily="34" charset="-122"/>
                 <a:cs typeface="Calibri" pitchFamily="34" charset="-120"/>
               </a:rPr>
-              <a:t>RECOMMENDED MEDIA</a:t>
+              <a:t>AI ENGINE</a:t>
             </a:r>
             <a:endParaRPr lang="en-US" sz="1100" dirty="0"/>
           </a:p>
@@ -4513,7 +4602,7 @@
                 <a:ea typeface="Calibri" pitchFamily="34" charset="-122"/>
                 <a:cs typeface="Calibri" pitchFamily="34" charset="-120"/>
               </a:rPr>
-              <a:t>Beyond the Library: High-Signal Strategy</a:t>
+              <a:t>CRAFT Starter Prompts: Brainstorm → Search → Make Sense</a:t>
             </a:r>
             <a:endParaRPr lang="en-US" sz="2600" dirty="0"/>
           </a:p>
@@ -4527,8 +4616,638 @@
         </p:nvSpPr>
         <p:spPr>
           <a:xfrm>
-            <a:off x="731520" y="1645920"/>
-            <a:ext cx="5212080" cy="4206240"/>
+            <a:off x="731520" y="1463040"/>
+            <a:ext cx="10698480" cy="1280160"/>
+          </a:xfrm>
+          <a:prstGeom prst="rect">
+            <a:avLst/>
+          </a:prstGeom>
+          <a:solidFill>
+            <a:srgbClr val="334155"/>
+          </a:solidFill>
+          <a:ln w="12700">
+            <a:solidFill>
+              <a:srgbClr val="475569"/>
+            </a:solidFill>
+            <a:prstDash val="solid"/>
+          </a:ln>
+        </p:spPr>
+      </p:sp>
+      <p:sp>
+        <p:nvSpPr>
+          <p:cNvPr id="5" name="Text 3"/>
+          <p:cNvSpPr/>
+          <p:nvPr/>
+        </p:nvSpPr>
+        <p:spPr>
+          <a:xfrm>
+            <a:off x="1005840" y="1645920"/>
+            <a:ext cx="2011680" cy="365760"/>
+          </a:xfrm>
+          <a:prstGeom prst="rect">
+            <a:avLst/>
+          </a:prstGeom>
+          <a:noFill/>
+          <a:ln/>
+        </p:spPr>
+        <p:txBody>
+          <a:bodyPr wrap="square" rtlCol="0" anchor="ctr"/>
+          <a:lstStyle/>
+          <a:p>
+            <a:pPr indent="0" marL="0">
+              <a:buNone/>
+            </a:pPr>
+            <a:r>
+              <a:rPr lang="en-US" sz="2000" b="1" dirty="0">
+                <a:solidFill>
+                  <a:srgbClr val="F59E0B"/>
+                </a:solidFill>
+                <a:latin typeface="Calibri" pitchFamily="34" charset="0"/>
+                <a:ea typeface="Calibri" pitchFamily="34" charset="-122"/>
+                <a:cs typeface="Calibri" pitchFamily="34" charset="-120"/>
+              </a:rPr>
+              <a:t>01</a:t>
+            </a:r>
+            <a:endParaRPr lang="en-US" sz="2000" dirty="0"/>
+          </a:p>
+        </p:txBody>
+      </p:sp>
+      <p:sp>
+        <p:nvSpPr>
+          <p:cNvPr id="6" name="Text 4"/>
+          <p:cNvSpPr/>
+          <p:nvPr/>
+        </p:nvSpPr>
+        <p:spPr>
+          <a:xfrm>
+            <a:off x="1005840" y="2057400"/>
+            <a:ext cx="2011680" cy="548640"/>
+          </a:xfrm>
+          <a:prstGeom prst="rect">
+            <a:avLst/>
+          </a:prstGeom>
+          <a:noFill/>
+          <a:ln/>
+        </p:spPr>
+        <p:txBody>
+          <a:bodyPr wrap="square" rtlCol="0" anchor="t"/>
+          <a:lstStyle/>
+          <a:p>
+            <a:pPr indent="0" marL="0">
+              <a:buNone/>
+            </a:pPr>
+            <a:r>
+              <a:rPr lang="en-US" sz="1200" b="1" spc="100" kern="0" dirty="0">
+                <a:solidFill>
+                  <a:srgbClr val="94A3B8"/>
+                </a:solidFill>
+                <a:latin typeface="Calibri" pitchFamily="34" charset="0"/>
+                <a:ea typeface="Calibri" pitchFamily="34" charset="-122"/>
+                <a:cs typeface="Calibri" pitchFamily="34" charset="-120"/>
+              </a:rPr>
+              <a:t>BRAINSTORM</a:t>
+            </a:r>
+            <a:endParaRPr lang="en-US" sz="1200" dirty="0"/>
+          </a:p>
+        </p:txBody>
+      </p:sp>
+      <p:sp>
+        <p:nvSpPr>
+          <p:cNvPr id="7" name="Text 5"/>
+          <p:cNvSpPr/>
+          <p:nvPr/>
+        </p:nvSpPr>
+        <p:spPr>
+          <a:xfrm>
+            <a:off x="3108960" y="1600200"/>
+            <a:ext cx="8046720" cy="1005840"/>
+          </a:xfrm>
+          <a:prstGeom prst="rect">
+            <a:avLst/>
+          </a:prstGeom>
+          <a:noFill/>
+          <a:ln/>
+        </p:spPr>
+        <p:txBody>
+          <a:bodyPr wrap="square" rtlCol="0" anchor="ctr"/>
+          <a:lstStyle/>
+          <a:p>
+            <a:pPr indent="0" marL="0">
+              <a:lnSpc>
+                <a:spcPts val="2000"/>
+              </a:lnSpc>
+              <a:buNone/>
+            </a:pPr>
+            <a:r>
+              <a:rPr lang="en-US" sz="1400" dirty="0">
+                <a:solidFill>
+                  <a:srgbClr val="F8FAFC"/>
+                </a:solidFill>
+                <a:latin typeface="Calibri" pitchFamily="34" charset="0"/>
+                <a:ea typeface="Calibri" pitchFamily="34" charset="-122"/>
+                <a:cs typeface="Calibri" pitchFamily="34" charset="-120"/>
+              </a:rPr>
+              <a:t>"Act as a startup mentor</a:t>
+            </a:r>
+            <a:pPr indent="0" marL="0">
+              <a:lnSpc>
+                <a:spcPts val="2000"/>
+              </a:lnSpc>
+              <a:buNone/>
+            </a:pPr>
+            <a:r>
+              <a:rPr lang="en-US" sz="1400" b="1" dirty="0">
+                <a:solidFill>
+                  <a:srgbClr val="38BDF8"/>
+                </a:solidFill>
+                <a:latin typeface="Calibri" pitchFamily="34" charset="0"/>
+                <a:ea typeface="Calibri" pitchFamily="34" charset="-122"/>
+                <a:cs typeface="Calibri" pitchFamily="34" charset="-120"/>
+              </a:rPr>
+              <a:t> [ROLE]</a:t>
+            </a:r>
+            <a:pPr indent="0" marL="0">
+              <a:lnSpc>
+                <a:spcPts val="2000"/>
+              </a:lnSpc>
+              <a:buNone/>
+            </a:pPr>
+            <a:r>
+              <a:rPr lang="en-US" sz="1400" dirty="0">
+                <a:solidFill>
+                  <a:srgbClr val="F8FAFC"/>
+                </a:solidFill>
+                <a:latin typeface="Calibri" pitchFamily="34" charset="0"/>
+                <a:ea typeface="Calibri" pitchFamily="34" charset="-122"/>
+                <a:cs typeface="Calibri" pitchFamily="34" charset="-120"/>
+              </a:rPr>
+              <a:t>. I'm an engineering student with an idea for rentable food-production pods for small food makers</a:t>
+            </a:r>
+            <a:pPr indent="0" marL="0">
+              <a:lnSpc>
+                <a:spcPts val="2000"/>
+              </a:lnSpc>
+              <a:buNone/>
+            </a:pPr>
+            <a:r>
+              <a:rPr lang="en-US" sz="1400" b="1" dirty="0">
+                <a:solidFill>
+                  <a:srgbClr val="38BDF8"/>
+                </a:solidFill>
+                <a:latin typeface="Calibri" pitchFamily="34" charset="0"/>
+                <a:ea typeface="Calibri" pitchFamily="34" charset="-122"/>
+                <a:cs typeface="Calibri" pitchFamily="34" charset="-120"/>
+              </a:rPr>
+              <a:t> [CONTEXT]</a:t>
+            </a:r>
+            <a:pPr indent="0" marL="0">
+              <a:lnSpc>
+                <a:spcPts val="2000"/>
+              </a:lnSpc>
+              <a:buNone/>
+            </a:pPr>
+            <a:r>
+              <a:rPr lang="en-US" sz="1400" dirty="0">
+                <a:solidFill>
+                  <a:srgbClr val="F8FAFC"/>
+                </a:solidFill>
+                <a:latin typeface="Calibri" pitchFamily="34" charset="0"/>
+                <a:ea typeface="Calibri" pitchFamily="34" charset="-122"/>
+                <a:cs typeface="Calibri" pitchFamily="34" charset="-120"/>
+              </a:rPr>
+              <a:t>. List 5 questions I should answer before building a prototype</a:t>
+            </a:r>
+            <a:pPr indent="0" marL="0">
+              <a:lnSpc>
+                <a:spcPts val="2000"/>
+              </a:lnSpc>
+              <a:buNone/>
+            </a:pPr>
+            <a:r>
+              <a:rPr lang="en-US" sz="1400" b="1" dirty="0">
+                <a:solidFill>
+                  <a:srgbClr val="38BDF8"/>
+                </a:solidFill>
+                <a:latin typeface="Calibri" pitchFamily="34" charset="0"/>
+                <a:ea typeface="Calibri" pitchFamily="34" charset="-122"/>
+                <a:cs typeface="Calibri" pitchFamily="34" charset="-120"/>
+              </a:rPr>
+              <a:t> [ACTION]</a:t>
+            </a:r>
+            <a:pPr indent="0" marL="0">
+              <a:lnSpc>
+                <a:spcPts val="2000"/>
+              </a:lnSpc>
+              <a:buNone/>
+            </a:pPr>
+            <a:r>
+              <a:rPr lang="en-US" sz="1400" dirty="0">
+                <a:solidFill>
+                  <a:srgbClr val="F8FAFC"/>
+                </a:solidFill>
+                <a:latin typeface="Calibri" pitchFamily="34" charset="0"/>
+                <a:ea typeface="Calibri" pitchFamily="34" charset="-122"/>
+                <a:cs typeface="Calibri" pitchFamily="34" charset="-120"/>
+              </a:rPr>
+              <a:t> as a numbered list</a:t>
+            </a:r>
+            <a:pPr indent="0" marL="0">
+              <a:lnSpc>
+                <a:spcPts val="2000"/>
+              </a:lnSpc>
+              <a:buNone/>
+            </a:pPr>
+            <a:r>
+              <a:rPr lang="en-US" sz="1400" b="1" dirty="0">
+                <a:solidFill>
+                  <a:srgbClr val="38BDF8"/>
+                </a:solidFill>
+                <a:latin typeface="Calibri" pitchFamily="34" charset="0"/>
+                <a:ea typeface="Calibri" pitchFamily="34" charset="-122"/>
+                <a:cs typeface="Calibri" pitchFamily="34" charset="-120"/>
+              </a:rPr>
+              <a:t> [FORMAT]</a:t>
+            </a:r>
+            <a:pPr indent="0" marL="0">
+              <a:lnSpc>
+                <a:spcPts val="2000"/>
+              </a:lnSpc>
+              <a:buNone/>
+            </a:pPr>
+            <a:r>
+              <a:rPr lang="en-US" sz="1400" dirty="0">
+                <a:solidFill>
+                  <a:srgbClr val="F8FAFC"/>
+                </a:solidFill>
+                <a:latin typeface="Calibri" pitchFamily="34" charset="0"/>
+                <a:ea typeface="Calibri" pitchFamily="34" charset="-122"/>
+                <a:cs typeface="Calibri" pitchFamily="34" charset="-120"/>
+              </a:rPr>
+              <a:t>. Keep it simple and encouraging</a:t>
+            </a:r>
+            <a:pPr indent="0" marL="0">
+              <a:lnSpc>
+                <a:spcPts val="2000"/>
+              </a:lnSpc>
+              <a:buNone/>
+            </a:pPr>
+            <a:r>
+              <a:rPr lang="en-US" sz="1400" b="1" dirty="0">
+                <a:solidFill>
+                  <a:srgbClr val="38BDF8"/>
+                </a:solidFill>
+                <a:latin typeface="Calibri" pitchFamily="34" charset="0"/>
+                <a:ea typeface="Calibri" pitchFamily="34" charset="-122"/>
+                <a:cs typeface="Calibri" pitchFamily="34" charset="-120"/>
+              </a:rPr>
+              <a:t> [TONE]</a:t>
+            </a:r>
+            <a:pPr indent="0" marL="0">
+              <a:lnSpc>
+                <a:spcPts val="2000"/>
+              </a:lnSpc>
+              <a:buNone/>
+            </a:pPr>
+            <a:r>
+              <a:rPr lang="en-US" sz="1400" dirty="0">
+                <a:solidFill>
+                  <a:srgbClr val="F8FAFC"/>
+                </a:solidFill>
+                <a:latin typeface="Calibri" pitchFamily="34" charset="0"/>
+                <a:ea typeface="Calibri" pitchFamily="34" charset="-122"/>
+                <a:cs typeface="Calibri" pitchFamily="34" charset="-120"/>
+              </a:rPr>
+              <a:t>."</a:t>
+            </a:r>
+            <a:endParaRPr lang="en-US" sz="1400" dirty="0"/>
+          </a:p>
+        </p:txBody>
+      </p:sp>
+      <p:sp>
+        <p:nvSpPr>
+          <p:cNvPr id="8" name="Shape 6"/>
+          <p:cNvSpPr/>
+          <p:nvPr/>
+        </p:nvSpPr>
+        <p:spPr>
+          <a:xfrm>
+            <a:off x="731520" y="2926080"/>
+            <a:ext cx="10698480" cy="1280160"/>
+          </a:xfrm>
+          <a:prstGeom prst="rect">
+            <a:avLst/>
+          </a:prstGeom>
+          <a:solidFill>
+            <a:srgbClr val="334155"/>
+          </a:solidFill>
+          <a:ln w="12700">
+            <a:solidFill>
+              <a:srgbClr val="475569"/>
+            </a:solidFill>
+            <a:prstDash val="solid"/>
+          </a:ln>
+        </p:spPr>
+      </p:sp>
+      <p:sp>
+        <p:nvSpPr>
+          <p:cNvPr id="9" name="Text 7"/>
+          <p:cNvSpPr/>
+          <p:nvPr/>
+        </p:nvSpPr>
+        <p:spPr>
+          <a:xfrm>
+            <a:off x="1005840" y="3108960"/>
+            <a:ext cx="2011680" cy="365760"/>
+          </a:xfrm>
+          <a:prstGeom prst="rect">
+            <a:avLst/>
+          </a:prstGeom>
+          <a:noFill/>
+          <a:ln/>
+        </p:spPr>
+        <p:txBody>
+          <a:bodyPr wrap="square" rtlCol="0" anchor="ctr"/>
+          <a:lstStyle/>
+          <a:p>
+            <a:pPr indent="0" marL="0">
+              <a:buNone/>
+            </a:pPr>
+            <a:r>
+              <a:rPr lang="en-US" sz="2000" b="1" dirty="0">
+                <a:solidFill>
+                  <a:srgbClr val="F59E0B"/>
+                </a:solidFill>
+                <a:latin typeface="Calibri" pitchFamily="34" charset="0"/>
+                <a:ea typeface="Calibri" pitchFamily="34" charset="-122"/>
+                <a:cs typeface="Calibri" pitchFamily="34" charset="-120"/>
+              </a:rPr>
+              <a:t>02</a:t>
+            </a:r>
+            <a:endParaRPr lang="en-US" sz="2000" dirty="0"/>
+          </a:p>
+        </p:txBody>
+      </p:sp>
+      <p:sp>
+        <p:nvSpPr>
+          <p:cNvPr id="10" name="Text 8"/>
+          <p:cNvSpPr/>
+          <p:nvPr/>
+        </p:nvSpPr>
+        <p:spPr>
+          <a:xfrm>
+            <a:off x="1005840" y="3520440"/>
+            <a:ext cx="2011680" cy="548640"/>
+          </a:xfrm>
+          <a:prstGeom prst="rect">
+            <a:avLst/>
+          </a:prstGeom>
+          <a:noFill/>
+          <a:ln/>
+        </p:spPr>
+        <p:txBody>
+          <a:bodyPr wrap="square" rtlCol="0" anchor="t"/>
+          <a:lstStyle/>
+          <a:p>
+            <a:pPr indent="0" marL="0">
+              <a:buNone/>
+            </a:pPr>
+            <a:r>
+              <a:rPr lang="en-US" sz="1200" b="1" spc="100" kern="0" dirty="0">
+                <a:solidFill>
+                  <a:srgbClr val="94A3B8"/>
+                </a:solidFill>
+                <a:latin typeface="Calibri" pitchFamily="34" charset="0"/>
+                <a:ea typeface="Calibri" pitchFamily="34" charset="-122"/>
+                <a:cs typeface="Calibri" pitchFamily="34" charset="-120"/>
+              </a:rPr>
+              <a:t>FIND KEYWORDS</a:t>
+            </a:r>
+            <a:endParaRPr lang="en-US" sz="1200" dirty="0"/>
+          </a:p>
+        </p:txBody>
+      </p:sp>
+      <p:sp>
+        <p:nvSpPr>
+          <p:cNvPr id="11" name="Text 9"/>
+          <p:cNvSpPr/>
+          <p:nvPr/>
+        </p:nvSpPr>
+        <p:spPr>
+          <a:xfrm>
+            <a:off x="3108960" y="3063240"/>
+            <a:ext cx="8046720" cy="1005840"/>
+          </a:xfrm>
+          <a:prstGeom prst="rect">
+            <a:avLst/>
+          </a:prstGeom>
+          <a:noFill/>
+          <a:ln/>
+        </p:spPr>
+        <p:txBody>
+          <a:bodyPr wrap="square" rtlCol="0" anchor="ctr"/>
+          <a:lstStyle/>
+          <a:p>
+            <a:pPr indent="0" marL="0">
+              <a:lnSpc>
+                <a:spcPts val="2000"/>
+              </a:lnSpc>
+              <a:buNone/>
+            </a:pPr>
+            <a:r>
+              <a:rPr lang="en-US" sz="1400" dirty="0">
+                <a:solidFill>
+                  <a:srgbClr val="F8FAFC"/>
+                </a:solidFill>
+                <a:latin typeface="Calibri" pitchFamily="34" charset="0"/>
+                <a:ea typeface="Calibri" pitchFamily="34" charset="-122"/>
+                <a:cs typeface="Calibri" pitchFamily="34" charset="-120"/>
+              </a:rPr>
+              <a:t>"Act as a research librarian</a:t>
+            </a:r>
+            <a:pPr indent="0" marL="0">
+              <a:lnSpc>
+                <a:spcPts val="2000"/>
+              </a:lnSpc>
+              <a:buNone/>
+            </a:pPr>
+            <a:r>
+              <a:rPr lang="en-US" sz="1400" b="1" dirty="0">
+                <a:solidFill>
+                  <a:srgbClr val="38BDF8"/>
+                </a:solidFill>
+                <a:latin typeface="Calibri" pitchFamily="34" charset="0"/>
+                <a:ea typeface="Calibri" pitchFamily="34" charset="-122"/>
+                <a:cs typeface="Calibri" pitchFamily="34" charset="-120"/>
+              </a:rPr>
+              <a:t> [ROLE]</a:t>
+            </a:r>
+            <a:pPr indent="0" marL="0">
+              <a:lnSpc>
+                <a:spcPts val="2000"/>
+              </a:lnSpc>
+              <a:buNone/>
+            </a:pPr>
+            <a:r>
+              <a:rPr lang="en-US" sz="1400" dirty="0">
+                <a:solidFill>
+                  <a:srgbClr val="F8FAFC"/>
+                </a:solidFill>
+                <a:latin typeface="Calibri" pitchFamily="34" charset="0"/>
+                <a:ea typeface="Calibri" pitchFamily="34" charset="-122"/>
+                <a:cs typeface="Calibri" pitchFamily="34" charset="-120"/>
+              </a:rPr>
+              <a:t>. I'm researching the market for small-batch food manufacturing</a:t>
+            </a:r>
+            <a:pPr indent="0" marL="0">
+              <a:lnSpc>
+                <a:spcPts val="2000"/>
+              </a:lnSpc>
+              <a:buNone/>
+            </a:pPr>
+            <a:r>
+              <a:rPr lang="en-US" sz="1400" b="1" dirty="0">
+                <a:solidFill>
+                  <a:srgbClr val="38BDF8"/>
+                </a:solidFill>
+                <a:latin typeface="Calibri" pitchFamily="34" charset="0"/>
+                <a:ea typeface="Calibri" pitchFamily="34" charset="-122"/>
+                <a:cs typeface="Calibri" pitchFamily="34" charset="-120"/>
+              </a:rPr>
+              <a:t> [CONTEXT]</a:t>
+            </a:r>
+            <a:pPr indent="0" marL="0">
+              <a:lnSpc>
+                <a:spcPts val="2000"/>
+              </a:lnSpc>
+              <a:buNone/>
+            </a:pPr>
+            <a:r>
+              <a:rPr lang="en-US" sz="1400" dirty="0">
+                <a:solidFill>
+                  <a:srgbClr val="F8FAFC"/>
+                </a:solidFill>
+                <a:latin typeface="Calibri" pitchFamily="34" charset="0"/>
+                <a:ea typeface="Calibri" pitchFamily="34" charset="-122"/>
+                <a:cs typeface="Calibri" pitchFamily="34" charset="-120"/>
+              </a:rPr>
+              <a:t>. Suggest 10 keywords and synonyms I can search in IBISWorld or Statista</a:t>
+            </a:r>
+            <a:pPr indent="0" marL="0">
+              <a:lnSpc>
+                <a:spcPts val="2000"/>
+              </a:lnSpc>
+              <a:buNone/>
+            </a:pPr>
+            <a:r>
+              <a:rPr lang="en-US" sz="1400" b="1" dirty="0">
+                <a:solidFill>
+                  <a:srgbClr val="38BDF8"/>
+                </a:solidFill>
+                <a:latin typeface="Calibri" pitchFamily="34" charset="0"/>
+                <a:ea typeface="Calibri" pitchFamily="34" charset="-122"/>
+                <a:cs typeface="Calibri" pitchFamily="34" charset="-120"/>
+              </a:rPr>
+              <a:t> [ACTION]</a:t>
+            </a:r>
+            <a:pPr indent="0" marL="0">
+              <a:lnSpc>
+                <a:spcPts val="2000"/>
+              </a:lnSpc>
+              <a:buNone/>
+            </a:pPr>
+            <a:r>
+              <a:rPr lang="en-US" sz="1400" dirty="0">
+                <a:solidFill>
+                  <a:srgbClr val="F8FAFC"/>
+                </a:solidFill>
+                <a:latin typeface="Calibri" pitchFamily="34" charset="0"/>
+                <a:ea typeface="Calibri" pitchFamily="34" charset="-122"/>
+                <a:cs typeface="Calibri" pitchFamily="34" charset="-120"/>
+              </a:rPr>
+              <a:t> as a table: keyword | why it helps</a:t>
+            </a:r>
+            <a:pPr indent="0" marL="0">
+              <a:lnSpc>
+                <a:spcPts val="2000"/>
+              </a:lnSpc>
+              <a:buNone/>
+            </a:pPr>
+            <a:r>
+              <a:rPr lang="en-US" sz="1400" b="1" dirty="0">
+                <a:solidFill>
+                  <a:srgbClr val="38BDF8"/>
+                </a:solidFill>
+                <a:latin typeface="Calibri" pitchFamily="34" charset="0"/>
+                <a:ea typeface="Calibri" pitchFamily="34" charset="-122"/>
+                <a:cs typeface="Calibri" pitchFamily="34" charset="-120"/>
+              </a:rPr>
+              <a:t> [FORMAT]</a:t>
+            </a:r>
+            <a:pPr indent="0" marL="0">
+              <a:lnSpc>
+                <a:spcPts val="2000"/>
+              </a:lnSpc>
+              <a:buNone/>
+            </a:pPr>
+            <a:r>
+              <a:rPr lang="en-US" sz="1400" dirty="0">
+                <a:solidFill>
+                  <a:srgbClr val="F8FAFC"/>
+                </a:solidFill>
+                <a:latin typeface="Calibri" pitchFamily="34" charset="0"/>
+                <a:ea typeface="Calibri" pitchFamily="34" charset="-122"/>
+                <a:cs typeface="Calibri" pitchFamily="34" charset="-120"/>
+              </a:rPr>
+              <a:t>. Plain and practical</a:t>
+            </a:r>
+            <a:pPr indent="0" marL="0">
+              <a:lnSpc>
+                <a:spcPts val="2000"/>
+              </a:lnSpc>
+              <a:buNone/>
+            </a:pPr>
+            <a:r>
+              <a:rPr lang="en-US" sz="1400" b="1" dirty="0">
+                <a:solidFill>
+                  <a:srgbClr val="38BDF8"/>
+                </a:solidFill>
+                <a:latin typeface="Calibri" pitchFamily="34" charset="0"/>
+                <a:ea typeface="Calibri" pitchFamily="34" charset="-122"/>
+                <a:cs typeface="Calibri" pitchFamily="34" charset="-120"/>
+              </a:rPr>
+              <a:t> [TONE]</a:t>
+            </a:r>
+            <a:pPr indent="0" marL="0">
+              <a:lnSpc>
+                <a:spcPts val="2000"/>
+              </a:lnSpc>
+              <a:buNone/>
+            </a:pPr>
+            <a:r>
+              <a:rPr lang="en-US" sz="1400" dirty="0">
+                <a:solidFill>
+                  <a:srgbClr val="F8FAFC"/>
+                </a:solidFill>
+                <a:latin typeface="Calibri" pitchFamily="34" charset="0"/>
+                <a:ea typeface="Calibri" pitchFamily="34" charset="-122"/>
+                <a:cs typeface="Calibri" pitchFamily="34" charset="-120"/>
+              </a:rPr>
+              <a:t>."</a:t>
+            </a:r>
+            <a:endParaRPr lang="en-US" sz="1400" dirty="0"/>
+          </a:p>
+        </p:txBody>
+      </p:sp>
+      <p:sp>
+        <p:nvSpPr>
+          <p:cNvPr id="12" name="Shape 10"/>
+          <p:cNvSpPr/>
+          <p:nvPr/>
+        </p:nvSpPr>
+        <p:spPr>
+          <a:xfrm>
+            <a:off x="731520" y="4389120"/>
+            <a:ext cx="10698480" cy="1280160"/>
           </a:xfrm>
           <a:prstGeom prst="rect">
             <a:avLst/>
@@ -4546,14 +5265,14 @@
       </p:sp>
       <p:sp>
         <p:nvSpPr>
-          <p:cNvPr id="5" name="Text 3"/>
-          <p:cNvSpPr/>
-          <p:nvPr/>
-        </p:nvSpPr>
-        <p:spPr>
-          <a:xfrm>
-            <a:off x="1097280" y="2011680"/>
-            <a:ext cx="4480560" cy="365760"/>
+          <p:cNvPr id="13" name="Text 11"/>
+          <p:cNvSpPr/>
+          <p:nvPr/>
+        </p:nvSpPr>
+        <p:spPr>
+          <a:xfrm>
+            <a:off x="1005840" y="4572000"/>
+            <a:ext cx="2011680" cy="365760"/>
           </a:xfrm>
           <a:prstGeom prst="rect">
             <a:avLst/>
@@ -4571,44 +5290,295 @@
             <a:r>
               <a:rPr lang="en-US" sz="2000" b="1" dirty="0">
                 <a:solidFill>
+                  <a:srgbClr val="F59E0B"/>
+                </a:solidFill>
+                <a:latin typeface="Calibri" pitchFamily="34" charset="0"/>
+                <a:ea typeface="Calibri" pitchFamily="34" charset="-122"/>
+                <a:cs typeface="Calibri" pitchFamily="34" charset="-120"/>
+              </a:rPr>
+              <a:t>03</a:t>
+            </a:r>
+            <a:endParaRPr lang="en-US" sz="2000" dirty="0"/>
+          </a:p>
+        </p:txBody>
+      </p:sp>
+      <p:sp>
+        <p:nvSpPr>
+          <p:cNvPr id="14" name="Text 12"/>
+          <p:cNvSpPr/>
+          <p:nvPr/>
+        </p:nvSpPr>
+        <p:spPr>
+          <a:xfrm>
+            <a:off x="1005840" y="4983480"/>
+            <a:ext cx="2011680" cy="548640"/>
+          </a:xfrm>
+          <a:prstGeom prst="rect">
+            <a:avLst/>
+          </a:prstGeom>
+          <a:noFill/>
+          <a:ln/>
+        </p:spPr>
+        <p:txBody>
+          <a:bodyPr wrap="square" rtlCol="0" anchor="t"/>
+          <a:lstStyle/>
+          <a:p>
+            <a:pPr indent="0" marL="0">
+              <a:buNone/>
+            </a:pPr>
+            <a:r>
+              <a:rPr lang="en-US" sz="1200" b="1" spc="100" kern="0" dirty="0">
+                <a:solidFill>
+                  <a:srgbClr val="94A3B8"/>
+                </a:solidFill>
+                <a:latin typeface="Calibri" pitchFamily="34" charset="0"/>
+                <a:ea typeface="Calibri" pitchFamily="34" charset="-122"/>
+                <a:cs typeface="Calibri" pitchFamily="34" charset="-120"/>
+              </a:rPr>
+              <a:t>MAKE SENSE OF A SOURCE</a:t>
+            </a:r>
+            <a:endParaRPr lang="en-US" sz="1200" dirty="0"/>
+          </a:p>
+        </p:txBody>
+      </p:sp>
+      <p:sp>
+        <p:nvSpPr>
+          <p:cNvPr id="15" name="Text 13"/>
+          <p:cNvSpPr/>
+          <p:nvPr/>
+        </p:nvSpPr>
+        <p:spPr>
+          <a:xfrm>
+            <a:off x="3108960" y="4526280"/>
+            <a:ext cx="8046720" cy="1005840"/>
+          </a:xfrm>
+          <a:prstGeom prst="rect">
+            <a:avLst/>
+          </a:prstGeom>
+          <a:noFill/>
+          <a:ln/>
+        </p:spPr>
+        <p:txBody>
+          <a:bodyPr wrap="square" rtlCol="0" anchor="ctr"/>
+          <a:lstStyle/>
+          <a:p>
+            <a:pPr indent="0" marL="0">
+              <a:lnSpc>
+                <a:spcPts val="2000"/>
+              </a:lnSpc>
+              <a:buNone/>
+            </a:pPr>
+            <a:r>
+              <a:rPr lang="en-US" sz="1400" dirty="0">
+                <a:solidFill>
+                  <a:srgbClr val="F8FAFC"/>
+                </a:solidFill>
+                <a:latin typeface="Calibri" pitchFamily="34" charset="0"/>
+                <a:ea typeface="Calibri" pitchFamily="34" charset="-122"/>
+                <a:cs typeface="Calibri" pitchFamily="34" charset="-120"/>
+              </a:rPr>
+              <a:t>"Act as a teaching assistant</a:t>
+            </a:r>
+            <a:pPr indent="0" marL="0">
+              <a:lnSpc>
+                <a:spcPts val="2000"/>
+              </a:lnSpc>
+              <a:buNone/>
+            </a:pPr>
+            <a:r>
+              <a:rPr lang="en-US" sz="1400" b="1" dirty="0">
+                <a:solidFill>
                   <a:srgbClr val="38BDF8"/>
                 </a:solidFill>
                 <a:latin typeface="Calibri" pitchFamily="34" charset="0"/>
                 <a:ea typeface="Calibri" pitchFamily="34" charset="-122"/>
                 <a:cs typeface="Calibri" pitchFamily="34" charset="-120"/>
               </a:rPr>
-              <a:t>ACQUIRED PODCAST</a:t>
-            </a:r>
-            <a:endParaRPr lang="en-US" sz="2000" dirty="0"/>
-          </a:p>
-        </p:txBody>
-      </p:sp>
-      <p:sp>
-        <p:nvSpPr>
-          <p:cNvPr id="6" name="Text 4"/>
-          <p:cNvSpPr/>
-          <p:nvPr/>
-        </p:nvSpPr>
-        <p:spPr>
-          <a:xfrm>
-            <a:off x="1097280" y="2377440"/>
-            <a:ext cx="4480560" cy="274320"/>
-          </a:xfrm>
-          <a:prstGeom prst="rect">
-            <a:avLst/>
-          </a:prstGeom>
-          <a:noFill/>
-          <a:ln/>
-        </p:spPr>
-        <p:txBody>
-          <a:bodyPr wrap="square" rtlCol="0" anchor="ctr"/>
-          <a:lstStyle/>
-          <a:p>
-            <a:pPr indent="0" marL="0">
-              <a:buNone/>
-            </a:pPr>
-            <a:r>
-              <a:rPr lang="en-US" sz="1200" i="1" dirty="0">
+              <a:t> [ROLE]</a:t>
+            </a:r>
+            <a:pPr indent="0" marL="0">
+              <a:lnSpc>
+                <a:spcPts val="2000"/>
+              </a:lnSpc>
+              <a:buNone/>
+            </a:pPr>
+            <a:r>
+              <a:rPr lang="en-US" sz="1400" dirty="0">
+                <a:solidFill>
+                  <a:srgbClr val="F8FAFC"/>
+                </a:solidFill>
+                <a:latin typeface="Calibri" pitchFamily="34" charset="0"/>
+                <a:ea typeface="Calibri" pitchFamily="34" charset="-122"/>
+                <a:cs typeface="Calibri" pitchFamily="34" charset="-120"/>
+              </a:rPr>
+              <a:t>. Below is a section of an IBISWorld report I pasted in</a:t>
+            </a:r>
+            <a:pPr indent="0" marL="0">
+              <a:lnSpc>
+                <a:spcPts val="2000"/>
+              </a:lnSpc>
+              <a:buNone/>
+            </a:pPr>
+            <a:r>
+              <a:rPr lang="en-US" sz="1400" b="1" dirty="0">
+                <a:solidFill>
+                  <a:srgbClr val="38BDF8"/>
+                </a:solidFill>
+                <a:latin typeface="Calibri" pitchFamily="34" charset="0"/>
+                <a:ea typeface="Calibri" pitchFamily="34" charset="-122"/>
+                <a:cs typeface="Calibri" pitchFamily="34" charset="-120"/>
+              </a:rPr>
+              <a:t> [CONTEXT]</a:t>
+            </a:r>
+            <a:pPr indent="0" marL="0">
+              <a:lnSpc>
+                <a:spcPts val="2000"/>
+              </a:lnSpc>
+              <a:buNone/>
+            </a:pPr>
+            <a:r>
+              <a:rPr lang="en-US" sz="1400" dirty="0">
+                <a:solidFill>
+                  <a:srgbClr val="F8FAFC"/>
+                </a:solidFill>
+                <a:latin typeface="Calibri" pitchFamily="34" charset="0"/>
+                <a:ea typeface="Calibri" pitchFamily="34" charset="-122"/>
+                <a:cs typeface="Calibri" pitchFamily="34" charset="-120"/>
+              </a:rPr>
+              <a:t>. Explain the 3 most important takeaways for a new business</a:t>
+            </a:r>
+            <a:pPr indent="0" marL="0">
+              <a:lnSpc>
+                <a:spcPts val="2000"/>
+              </a:lnSpc>
+              <a:buNone/>
+            </a:pPr>
+            <a:r>
+              <a:rPr lang="en-US" sz="1400" b="1" dirty="0">
+                <a:solidFill>
+                  <a:srgbClr val="38BDF8"/>
+                </a:solidFill>
+                <a:latin typeface="Calibri" pitchFamily="34" charset="0"/>
+                <a:ea typeface="Calibri" pitchFamily="34" charset="-122"/>
+                <a:cs typeface="Calibri" pitchFamily="34" charset="-120"/>
+              </a:rPr>
+              <a:t> [ACTION]</a:t>
+            </a:r>
+            <a:pPr indent="0" marL="0">
+              <a:lnSpc>
+                <a:spcPts val="2000"/>
+              </a:lnSpc>
+              <a:buNone/>
+            </a:pPr>
+            <a:r>
+              <a:rPr lang="en-US" sz="1400" dirty="0">
+                <a:solidFill>
+                  <a:srgbClr val="F8FAFC"/>
+                </a:solidFill>
+                <a:latin typeface="Calibri" pitchFamily="34" charset="0"/>
+                <a:ea typeface="Calibri" pitchFamily="34" charset="-122"/>
+                <a:cs typeface="Calibri" pitchFamily="34" charset="-120"/>
+              </a:rPr>
+              <a:t> in 3 short bullet points</a:t>
+            </a:r>
+            <a:pPr indent="0" marL="0">
+              <a:lnSpc>
+                <a:spcPts val="2000"/>
+              </a:lnSpc>
+              <a:buNone/>
+            </a:pPr>
+            <a:r>
+              <a:rPr lang="en-US" sz="1400" b="1" dirty="0">
+                <a:solidFill>
+                  <a:srgbClr val="38BDF8"/>
+                </a:solidFill>
+                <a:latin typeface="Calibri" pitchFamily="34" charset="0"/>
+                <a:ea typeface="Calibri" pitchFamily="34" charset="-122"/>
+                <a:cs typeface="Calibri" pitchFamily="34" charset="-120"/>
+              </a:rPr>
+              <a:t> [FORMAT]</a:t>
+            </a:r>
+            <a:pPr indent="0" marL="0">
+              <a:lnSpc>
+                <a:spcPts val="2000"/>
+              </a:lnSpc>
+              <a:buNone/>
+            </a:pPr>
+            <a:r>
+              <a:rPr lang="en-US" sz="1400" dirty="0">
+                <a:solidFill>
+                  <a:srgbClr val="F8FAFC"/>
+                </a:solidFill>
+                <a:latin typeface="Calibri" pitchFamily="34" charset="0"/>
+                <a:ea typeface="Calibri" pitchFamily="34" charset="-122"/>
+                <a:cs typeface="Calibri" pitchFamily="34" charset="-120"/>
+              </a:rPr>
+              <a:t>. Plain language, no jargon</a:t>
+            </a:r>
+            <a:pPr indent="0" marL="0">
+              <a:lnSpc>
+                <a:spcPts val="2000"/>
+              </a:lnSpc>
+              <a:buNone/>
+            </a:pPr>
+            <a:r>
+              <a:rPr lang="en-US" sz="1400" b="1" dirty="0">
+                <a:solidFill>
+                  <a:srgbClr val="38BDF8"/>
+                </a:solidFill>
+                <a:latin typeface="Calibri" pitchFamily="34" charset="0"/>
+                <a:ea typeface="Calibri" pitchFamily="34" charset="-122"/>
+                <a:cs typeface="Calibri" pitchFamily="34" charset="-120"/>
+              </a:rPr>
+              <a:t> [TONE]</a:t>
+            </a:r>
+            <a:pPr indent="0" marL="0">
+              <a:lnSpc>
+                <a:spcPts val="2000"/>
+              </a:lnSpc>
+              <a:buNone/>
+            </a:pPr>
+            <a:r>
+              <a:rPr lang="en-US" sz="1400" dirty="0">
+                <a:solidFill>
+                  <a:srgbClr val="F8FAFC"/>
+                </a:solidFill>
+                <a:latin typeface="Calibri" pitchFamily="34" charset="0"/>
+                <a:ea typeface="Calibri" pitchFamily="34" charset="-122"/>
+                <a:cs typeface="Calibri" pitchFamily="34" charset="-120"/>
+              </a:rPr>
+              <a:t>."</a:t>
+            </a:r>
+            <a:endParaRPr lang="en-US" sz="1400" dirty="0"/>
+          </a:p>
+        </p:txBody>
+      </p:sp>
+      <p:sp>
+        <p:nvSpPr>
+          <p:cNvPr id="16" name="Text 14"/>
+          <p:cNvSpPr/>
+          <p:nvPr/>
+        </p:nvSpPr>
+        <p:spPr>
+          <a:xfrm>
+            <a:off x="731520" y="5852160"/>
+            <a:ext cx="10698480" cy="365760"/>
+          </a:xfrm>
+          <a:prstGeom prst="rect">
+            <a:avLst/>
+          </a:prstGeom>
+          <a:noFill/>
+          <a:ln/>
+        </p:spPr>
+        <p:txBody>
+          <a:bodyPr wrap="square" rtlCol="0" anchor="ctr"/>
+          <a:lstStyle/>
+          <a:p>
+            <a:pPr algn="ctr" indent="0" marL="0">
+              <a:buNone/>
+            </a:pPr>
+            <a:r>
+              <a:rPr lang="en-US" sz="1300" i="1" dirty="0">
                 <a:solidFill>
                   <a:srgbClr val="94A3B8"/>
                 </a:solidFill>
@@ -4616,202 +5586,15 @@
                 <a:ea typeface="Calibri" pitchFamily="34" charset="-122"/>
                 <a:cs typeface="Calibri" pitchFamily="34" charset="-120"/>
               </a:rPr>
-              <a:t>Ben Gilbert &amp; David Rosenthal</a:t>
-            </a:r>
-            <a:endParaRPr lang="en-US" sz="1200" dirty="0"/>
-          </a:p>
-        </p:txBody>
-      </p:sp>
-      <p:sp>
-        <p:nvSpPr>
-          <p:cNvPr id="7" name="Text 5"/>
-          <p:cNvSpPr/>
-          <p:nvPr/>
-        </p:nvSpPr>
-        <p:spPr>
-          <a:xfrm>
-            <a:off x="1097280" y="2926080"/>
-            <a:ext cx="4480560" cy="2560320"/>
-          </a:xfrm>
-          <a:prstGeom prst="rect">
-            <a:avLst/>
-          </a:prstGeom>
-          <a:noFill/>
-          <a:ln/>
-        </p:spPr>
-        <p:txBody>
-          <a:bodyPr wrap="square" rtlCol="0" anchor="t"/>
-          <a:lstStyle/>
-          <a:p>
-            <a:pPr indent="0" marL="0">
-              <a:lnSpc>
-                <a:spcPts val="2400"/>
-              </a:lnSpc>
-              <a:buNone/>
-            </a:pPr>
-            <a:r>
-              <a:rPr lang="en-US" sz="1500" dirty="0">
-                <a:solidFill>
-                  <a:srgbClr val="F8FAFC"/>
-                </a:solidFill>
-                <a:latin typeface="Calibri" pitchFamily="34" charset="0"/>
-                <a:ea typeface="Calibri" pitchFamily="34" charset="-122"/>
-                <a:cs typeface="Calibri" pitchFamily="34" charset="-120"/>
-              </a:rPr>
-              <a:t>3-hour corporate biographies &amp; strategy teardowns (NVIDIA, TSMC, Skunk Works). Learn how technical subsystems scale into super-systems.</a:t>
-            </a:r>
-            <a:endParaRPr lang="en-US" sz="1500" dirty="0"/>
-          </a:p>
-        </p:txBody>
-      </p:sp>
-      <p:sp>
-        <p:nvSpPr>
-          <p:cNvPr id="8" name="Shape 6"/>
-          <p:cNvSpPr/>
-          <p:nvPr/>
-        </p:nvSpPr>
-        <p:spPr>
-          <a:xfrm>
-            <a:off x="6217920" y="1645920"/>
-            <a:ext cx="5212080" cy="4206240"/>
-          </a:xfrm>
-          <a:prstGeom prst="rect">
-            <a:avLst/>
-          </a:prstGeom>
-          <a:solidFill>
-            <a:srgbClr val="334155"/>
-          </a:solidFill>
-          <a:ln w="19050">
-            <a:solidFill>
-              <a:srgbClr val="F59E0B"/>
-            </a:solidFill>
-            <a:prstDash val="solid"/>
-          </a:ln>
-        </p:spPr>
-      </p:sp>
-      <p:sp>
-        <p:nvSpPr>
-          <p:cNvPr id="9" name="Text 7"/>
-          <p:cNvSpPr/>
-          <p:nvPr/>
-        </p:nvSpPr>
-        <p:spPr>
-          <a:xfrm>
-            <a:off x="6583680" y="2011680"/>
-            <a:ext cx="4480560" cy="365760"/>
-          </a:xfrm>
-          <a:prstGeom prst="rect">
-            <a:avLst/>
-          </a:prstGeom>
-          <a:noFill/>
-          <a:ln/>
-        </p:spPr>
-        <p:txBody>
-          <a:bodyPr wrap="square" rtlCol="0" anchor="ctr"/>
-          <a:lstStyle/>
-          <a:p>
-            <a:pPr indent="0" marL="0">
-              <a:buNone/>
-            </a:pPr>
-            <a:r>
-              <a:rPr lang="en-US" sz="2000" b="1" dirty="0">
-                <a:solidFill>
-                  <a:srgbClr val="F59E0B"/>
-                </a:solidFill>
-                <a:latin typeface="Calibri" pitchFamily="34" charset="0"/>
-                <a:ea typeface="Calibri" pitchFamily="34" charset="-122"/>
-                <a:cs typeface="Calibri" pitchFamily="34" charset="-120"/>
-              </a:rPr>
-              <a:t>CORE MEMORY</a:t>
-            </a:r>
-            <a:endParaRPr lang="en-US" sz="2000" dirty="0"/>
-          </a:p>
-        </p:txBody>
-      </p:sp>
-      <p:sp>
-        <p:nvSpPr>
-          <p:cNvPr id="10" name="Text 8"/>
-          <p:cNvSpPr/>
-          <p:nvPr/>
-        </p:nvSpPr>
-        <p:spPr>
-          <a:xfrm>
-            <a:off x="6583680" y="2377440"/>
-            <a:ext cx="4480560" cy="274320"/>
-          </a:xfrm>
-          <a:prstGeom prst="rect">
-            <a:avLst/>
-          </a:prstGeom>
-          <a:noFill/>
-          <a:ln/>
-        </p:spPr>
-        <p:txBody>
-          <a:bodyPr wrap="square" rtlCol="0" anchor="ctr"/>
-          <a:lstStyle/>
-          <a:p>
-            <a:pPr indent="0" marL="0">
-              <a:buNone/>
-            </a:pPr>
-            <a:r>
-              <a:rPr lang="en-US" sz="1200" i="1" dirty="0">
-                <a:solidFill>
-                  <a:srgbClr val="94A3B8"/>
-                </a:solidFill>
-                <a:latin typeface="Calibri" pitchFamily="34" charset="0"/>
-                <a:ea typeface="Calibri" pitchFamily="34" charset="-122"/>
-                <a:cs typeface="Calibri" pitchFamily="34" charset="-120"/>
-              </a:rPr>
-              <a:t>Ashlee Vance</a:t>
-            </a:r>
-            <a:endParaRPr lang="en-US" sz="1200" dirty="0"/>
-          </a:p>
-        </p:txBody>
-      </p:sp>
-      <p:sp>
-        <p:nvSpPr>
-          <p:cNvPr id="11" name="Text 9"/>
-          <p:cNvSpPr/>
-          <p:nvPr/>
-        </p:nvSpPr>
-        <p:spPr>
-          <a:xfrm>
-            <a:off x="6583680" y="2926080"/>
-            <a:ext cx="4480560" cy="2560320"/>
-          </a:xfrm>
-          <a:prstGeom prst="rect">
-            <a:avLst/>
-          </a:prstGeom>
-          <a:noFill/>
-          <a:ln/>
-        </p:spPr>
-        <p:txBody>
-          <a:bodyPr wrap="square" rtlCol="0" anchor="t"/>
-          <a:lstStyle/>
-          <a:p>
-            <a:pPr indent="0" marL="0">
-              <a:lnSpc>
-                <a:spcPts val="2400"/>
-              </a:lnSpc>
-              <a:buNone/>
-            </a:pPr>
-            <a:r>
-              <a:rPr lang="en-US" sz="1500" dirty="0">
-                <a:solidFill>
-                  <a:srgbClr val="F8FAFC"/>
-                </a:solidFill>
-                <a:latin typeface="Calibri" pitchFamily="34" charset="0"/>
-                <a:ea typeface="Calibri" pitchFamily="34" charset="-122"/>
-                <a:cs typeface="Calibri" pitchFamily="34" charset="-120"/>
-              </a:rPr>
-              <a:t>Front-line reporting on hard tech, physical manufacturing, and frontier hardware. Essential perspective on atom-level engineering hurdles.</a:t>
-            </a:r>
-            <a:endParaRPr lang="en-US" sz="1500" dirty="0"/>
-          </a:p>
-        </p:txBody>
-      </p:sp>
-      <p:sp>
-        <p:nvSpPr>
-          <p:cNvPr id="12" name="Text 10"/>
+              <a:t>Prompt 03 is the habit to build: paste the library source in first, then ask.</a:t>
+            </a:r>
+            <a:endParaRPr lang="en-US" sz="1300" dirty="0"/>
+          </a:p>
+        </p:txBody>
+      </p:sp>
+      <p:sp>
+        <p:nvSpPr>
+          <p:cNvPr id="17" name="Text 15"/>
           <p:cNvSpPr/>
           <p:nvPr/>
         </p:nvSpPr>
@@ -4859,6 +5642,445 @@
 <file path=ppt/slides/slide7.xml><?xml version="1.0" encoding="utf-8"?>
 <p:sld xmlns:a="http://schemas.openxmlformats.org/drawingml/2006/main" xmlns:r="http://schemas.openxmlformats.org/officeDocument/2006/relationships" xmlns:p="http://schemas.openxmlformats.org/presentationml/2006/main">
   <p:cSld name="Slide 7">
+    <p:bg>
+      <p:bgPr>
+        <a:solidFill>
+          <a:srgbClr val="1E293B"/>
+        </a:solidFill>
+      </p:bgPr>
+    </p:bg>
+    <p:spTree>
+      <p:nvGrpSpPr>
+        <p:cNvPr id="1" name=""/>
+        <p:cNvGrpSpPr/>
+        <p:nvPr/>
+      </p:nvGrpSpPr>
+      <p:grpSpPr>
+        <a:xfrm>
+          <a:off x="0" y="0"/>
+          <a:ext cx="0" cy="0"/>
+          <a:chOff x="0" y="0"/>
+          <a:chExt cx="0" cy="0"/>
+        </a:xfrm>
+      </p:grpSpPr>
+      <p:sp>
+        <p:nvSpPr>
+          <p:cNvPr id="2" name="Text 0"/>
+          <p:cNvSpPr/>
+          <p:nvPr/>
+        </p:nvSpPr>
+        <p:spPr>
+          <a:xfrm>
+            <a:off x="731520" y="457200"/>
+            <a:ext cx="10515600" cy="274320"/>
+          </a:xfrm>
+          <a:prstGeom prst="rect">
+            <a:avLst/>
+          </a:prstGeom>
+          <a:noFill/>
+          <a:ln/>
+        </p:spPr>
+        <p:txBody>
+          <a:bodyPr wrap="square" rtlCol="0" anchor="ctr"/>
+          <a:lstStyle/>
+          <a:p>
+            <a:pPr indent="0" marL="0">
+              <a:buNone/>
+            </a:pPr>
+            <a:r>
+              <a:rPr lang="en-US" sz="1100" b="1" spc="150" kern="0" dirty="0">
+                <a:solidFill>
+                  <a:srgbClr val="38BDF8"/>
+                </a:solidFill>
+                <a:latin typeface="Calibri" pitchFamily="34" charset="0"/>
+                <a:ea typeface="Calibri" pitchFamily="34" charset="-122"/>
+                <a:cs typeface="Calibri" pitchFamily="34" charset="-120"/>
+              </a:rPr>
+              <a:t>RECOMMENDED MEDIA</a:t>
+            </a:r>
+            <a:endParaRPr lang="en-US" sz="1100" dirty="0"/>
+          </a:p>
+        </p:txBody>
+      </p:sp>
+      <p:sp>
+        <p:nvSpPr>
+          <p:cNvPr id="3" name="Text 1"/>
+          <p:cNvSpPr/>
+          <p:nvPr/>
+        </p:nvSpPr>
+        <p:spPr>
+          <a:xfrm>
+            <a:off x="731520" y="731520"/>
+            <a:ext cx="10515600" cy="548640"/>
+          </a:xfrm>
+          <a:prstGeom prst="rect">
+            <a:avLst/>
+          </a:prstGeom>
+          <a:noFill/>
+          <a:ln/>
+        </p:spPr>
+        <p:txBody>
+          <a:bodyPr wrap="square" rtlCol="0" anchor="ctr"/>
+          <a:lstStyle/>
+          <a:p>
+            <a:pPr indent="0" marL="0">
+              <a:buNone/>
+            </a:pPr>
+            <a:r>
+              <a:rPr lang="en-US" sz="2600" b="1" dirty="0">
+                <a:solidFill>
+                  <a:srgbClr val="F8FAFC"/>
+                </a:solidFill>
+                <a:latin typeface="Calibri" pitchFamily="34" charset="0"/>
+                <a:ea typeface="Calibri" pitchFamily="34" charset="-122"/>
+                <a:cs typeface="Calibri" pitchFamily="34" charset="-120"/>
+              </a:rPr>
+              <a:t>Beyond the Library: High-Signal Strategy</a:t>
+            </a:r>
+            <a:endParaRPr lang="en-US" sz="2600" dirty="0"/>
+          </a:p>
+        </p:txBody>
+      </p:sp>
+      <p:sp>
+        <p:nvSpPr>
+          <p:cNvPr id="4" name="Shape 2"/>
+          <p:cNvSpPr/>
+          <p:nvPr/>
+        </p:nvSpPr>
+        <p:spPr>
+          <a:xfrm>
+            <a:off x="731520" y="1645920"/>
+            <a:ext cx="5212080" cy="4206240"/>
+          </a:xfrm>
+          <a:prstGeom prst="rect">
+            <a:avLst/>
+          </a:prstGeom>
+          <a:solidFill>
+            <a:srgbClr val="334155"/>
+          </a:solidFill>
+          <a:ln w="19050">
+            <a:solidFill>
+              <a:srgbClr val="38BDF8"/>
+            </a:solidFill>
+            <a:prstDash val="solid"/>
+          </a:ln>
+        </p:spPr>
+      </p:sp>
+      <p:sp>
+        <p:nvSpPr>
+          <p:cNvPr id="5" name="Text 3"/>
+          <p:cNvSpPr/>
+          <p:nvPr/>
+        </p:nvSpPr>
+        <p:spPr>
+          <a:xfrm>
+            <a:off x="1097280" y="2011680"/>
+            <a:ext cx="4480560" cy="365760"/>
+          </a:xfrm>
+          <a:prstGeom prst="rect">
+            <a:avLst/>
+          </a:prstGeom>
+          <a:noFill/>
+          <a:ln/>
+        </p:spPr>
+        <p:txBody>
+          <a:bodyPr wrap="square" rtlCol="0" anchor="ctr"/>
+          <a:lstStyle/>
+          <a:p>
+            <a:pPr indent="0" marL="0">
+              <a:buNone/>
+            </a:pPr>
+            <a:r>
+              <a:rPr lang="en-US" sz="2000" b="1" dirty="0">
+                <a:solidFill>
+                  <a:srgbClr val="38BDF8"/>
+                </a:solidFill>
+                <a:latin typeface="Calibri" pitchFamily="34" charset="0"/>
+                <a:ea typeface="Calibri" pitchFamily="34" charset="-122"/>
+                <a:cs typeface="Calibri" pitchFamily="34" charset="-120"/>
+              </a:rPr>
+              <a:t>ACQUIRED PODCAST</a:t>
+            </a:r>
+            <a:endParaRPr lang="en-US" sz="2000" dirty="0"/>
+          </a:p>
+        </p:txBody>
+      </p:sp>
+      <p:sp>
+        <p:nvSpPr>
+          <p:cNvPr id="6" name="Text 4"/>
+          <p:cNvSpPr/>
+          <p:nvPr/>
+        </p:nvSpPr>
+        <p:spPr>
+          <a:xfrm>
+            <a:off x="1097280" y="2377440"/>
+            <a:ext cx="4480560" cy="274320"/>
+          </a:xfrm>
+          <a:prstGeom prst="rect">
+            <a:avLst/>
+          </a:prstGeom>
+          <a:noFill/>
+          <a:ln/>
+        </p:spPr>
+        <p:txBody>
+          <a:bodyPr wrap="square" rtlCol="0" anchor="ctr"/>
+          <a:lstStyle/>
+          <a:p>
+            <a:pPr indent="0" marL="0">
+              <a:buNone/>
+            </a:pPr>
+            <a:r>
+              <a:rPr lang="en-US" sz="1200" i="1" dirty="0">
+                <a:solidFill>
+                  <a:srgbClr val="94A3B8"/>
+                </a:solidFill>
+                <a:latin typeface="Calibri" pitchFamily="34" charset="0"/>
+                <a:ea typeface="Calibri" pitchFamily="34" charset="-122"/>
+                <a:cs typeface="Calibri" pitchFamily="34" charset="-120"/>
+              </a:rPr>
+              <a:t>Ben Gilbert &amp; David Rosenthal</a:t>
+            </a:r>
+            <a:endParaRPr lang="en-US" sz="1200" dirty="0"/>
+          </a:p>
+        </p:txBody>
+      </p:sp>
+      <p:sp>
+        <p:nvSpPr>
+          <p:cNvPr id="7" name="Text 5"/>
+          <p:cNvSpPr/>
+          <p:nvPr/>
+        </p:nvSpPr>
+        <p:spPr>
+          <a:xfrm>
+            <a:off x="1097280" y="2926080"/>
+            <a:ext cx="4480560" cy="2560320"/>
+          </a:xfrm>
+          <a:prstGeom prst="rect">
+            <a:avLst/>
+          </a:prstGeom>
+          <a:noFill/>
+          <a:ln/>
+        </p:spPr>
+        <p:txBody>
+          <a:bodyPr wrap="square" rtlCol="0" anchor="t"/>
+          <a:lstStyle/>
+          <a:p>
+            <a:pPr indent="0" marL="0">
+              <a:lnSpc>
+                <a:spcPts val="2400"/>
+              </a:lnSpc>
+              <a:buNone/>
+            </a:pPr>
+            <a:r>
+              <a:rPr lang="en-US" sz="1500" dirty="0">
+                <a:solidFill>
+                  <a:srgbClr val="F8FAFC"/>
+                </a:solidFill>
+                <a:latin typeface="Calibri" pitchFamily="34" charset="0"/>
+                <a:ea typeface="Calibri" pitchFamily="34" charset="-122"/>
+                <a:cs typeface="Calibri" pitchFamily="34" charset="-120"/>
+              </a:rPr>
+              <a:t>3-hour corporate biographies &amp; strategy teardowns (NVIDIA, TSMC, Skunk Works). Learn how technical subsystems scale into super-systems.</a:t>
+            </a:r>
+            <a:endParaRPr lang="en-US" sz="1500" dirty="0"/>
+          </a:p>
+        </p:txBody>
+      </p:sp>
+      <p:sp>
+        <p:nvSpPr>
+          <p:cNvPr id="8" name="Shape 6"/>
+          <p:cNvSpPr/>
+          <p:nvPr/>
+        </p:nvSpPr>
+        <p:spPr>
+          <a:xfrm>
+            <a:off x="6217920" y="1645920"/>
+            <a:ext cx="5212080" cy="4206240"/>
+          </a:xfrm>
+          <a:prstGeom prst="rect">
+            <a:avLst/>
+          </a:prstGeom>
+          <a:solidFill>
+            <a:srgbClr val="334155"/>
+          </a:solidFill>
+          <a:ln w="19050">
+            <a:solidFill>
+              <a:srgbClr val="F59E0B"/>
+            </a:solidFill>
+            <a:prstDash val="solid"/>
+          </a:ln>
+        </p:spPr>
+      </p:sp>
+      <p:sp>
+        <p:nvSpPr>
+          <p:cNvPr id="9" name="Text 7"/>
+          <p:cNvSpPr/>
+          <p:nvPr/>
+        </p:nvSpPr>
+        <p:spPr>
+          <a:xfrm>
+            <a:off x="6583680" y="2011680"/>
+            <a:ext cx="4480560" cy="365760"/>
+          </a:xfrm>
+          <a:prstGeom prst="rect">
+            <a:avLst/>
+          </a:prstGeom>
+          <a:noFill/>
+          <a:ln/>
+        </p:spPr>
+        <p:txBody>
+          <a:bodyPr wrap="square" rtlCol="0" anchor="ctr"/>
+          <a:lstStyle/>
+          <a:p>
+            <a:pPr indent="0" marL="0">
+              <a:buNone/>
+            </a:pPr>
+            <a:r>
+              <a:rPr lang="en-US" sz="2000" b="1" dirty="0">
+                <a:solidFill>
+                  <a:srgbClr val="F59E0B"/>
+                </a:solidFill>
+                <a:latin typeface="Calibri" pitchFamily="34" charset="0"/>
+                <a:ea typeface="Calibri" pitchFamily="34" charset="-122"/>
+                <a:cs typeface="Calibri" pitchFamily="34" charset="-120"/>
+              </a:rPr>
+              <a:t>CORE MEMORY</a:t>
+            </a:r>
+            <a:endParaRPr lang="en-US" sz="2000" dirty="0"/>
+          </a:p>
+        </p:txBody>
+      </p:sp>
+      <p:sp>
+        <p:nvSpPr>
+          <p:cNvPr id="10" name="Text 8"/>
+          <p:cNvSpPr/>
+          <p:nvPr/>
+        </p:nvSpPr>
+        <p:spPr>
+          <a:xfrm>
+            <a:off x="6583680" y="2377440"/>
+            <a:ext cx="4480560" cy="274320"/>
+          </a:xfrm>
+          <a:prstGeom prst="rect">
+            <a:avLst/>
+          </a:prstGeom>
+          <a:noFill/>
+          <a:ln/>
+        </p:spPr>
+        <p:txBody>
+          <a:bodyPr wrap="square" rtlCol="0" anchor="ctr"/>
+          <a:lstStyle/>
+          <a:p>
+            <a:pPr indent="0" marL="0">
+              <a:buNone/>
+            </a:pPr>
+            <a:r>
+              <a:rPr lang="en-US" sz="1200" i="1" dirty="0">
+                <a:solidFill>
+                  <a:srgbClr val="94A3B8"/>
+                </a:solidFill>
+                <a:latin typeface="Calibri" pitchFamily="34" charset="0"/>
+                <a:ea typeface="Calibri" pitchFamily="34" charset="-122"/>
+                <a:cs typeface="Calibri" pitchFamily="34" charset="-120"/>
+              </a:rPr>
+              <a:t>Ashlee Vance</a:t>
+            </a:r>
+            <a:endParaRPr lang="en-US" sz="1200" dirty="0"/>
+          </a:p>
+        </p:txBody>
+      </p:sp>
+      <p:sp>
+        <p:nvSpPr>
+          <p:cNvPr id="11" name="Text 9"/>
+          <p:cNvSpPr/>
+          <p:nvPr/>
+        </p:nvSpPr>
+        <p:spPr>
+          <a:xfrm>
+            <a:off x="6583680" y="2926080"/>
+            <a:ext cx="4480560" cy="2560320"/>
+          </a:xfrm>
+          <a:prstGeom prst="rect">
+            <a:avLst/>
+          </a:prstGeom>
+          <a:noFill/>
+          <a:ln/>
+        </p:spPr>
+        <p:txBody>
+          <a:bodyPr wrap="square" rtlCol="0" anchor="t"/>
+          <a:lstStyle/>
+          <a:p>
+            <a:pPr indent="0" marL="0">
+              <a:lnSpc>
+                <a:spcPts val="2400"/>
+              </a:lnSpc>
+              <a:buNone/>
+            </a:pPr>
+            <a:r>
+              <a:rPr lang="en-US" sz="1500" dirty="0">
+                <a:solidFill>
+                  <a:srgbClr val="F8FAFC"/>
+                </a:solidFill>
+                <a:latin typeface="Calibri" pitchFamily="34" charset="0"/>
+                <a:ea typeface="Calibri" pitchFamily="34" charset="-122"/>
+                <a:cs typeface="Calibri" pitchFamily="34" charset="-120"/>
+              </a:rPr>
+              <a:t>Front-line reporting on hard tech, physical manufacturing, and frontier hardware. Essential perspective on atom-level engineering hurdles.</a:t>
+            </a:r>
+            <a:endParaRPr lang="en-US" sz="1500" dirty="0"/>
+          </a:p>
+        </p:txBody>
+      </p:sp>
+      <p:sp>
+        <p:nvSpPr>
+          <p:cNvPr id="12" name="Text 10"/>
+          <p:cNvSpPr/>
+          <p:nvPr/>
+        </p:nvSpPr>
+        <p:spPr>
+          <a:xfrm>
+            <a:off x="731520" y="6400800"/>
+            <a:ext cx="10698480" cy="274320"/>
+          </a:xfrm>
+          <a:prstGeom prst="rect">
+            <a:avLst/>
+          </a:prstGeom>
+          <a:noFill/>
+          <a:ln/>
+        </p:spPr>
+        <p:txBody>
+          <a:bodyPr wrap="square" rtlCol="0" anchor="ctr"/>
+          <a:lstStyle/>
+          <a:p>
+            <a:pPr indent="0" marL="0">
+              <a:buNone/>
+            </a:pPr>
+            <a:r>
+              <a:rPr lang="en-US" sz="1000" dirty="0">
+                <a:solidFill>
+                  <a:srgbClr val="94A3B8"/>
+                </a:solidFill>
+                <a:latin typeface="Calibri" pitchFamily="34" charset="0"/>
+                <a:ea typeface="Calibri" pitchFamily="34" charset="-122"/>
+                <a:cs typeface="Calibri" pitchFamily="34" charset="-120"/>
+              </a:rPr>
+              <a:t>EGR 440 | MSU Libraries Entrepreneurship Hub: libguides.lib.msu.edu/entrepreneur</a:t>
+            </a:r>
+            <a:endParaRPr lang="en-US" sz="1000" dirty="0"/>
+          </a:p>
+        </p:txBody>
+      </p:sp>
+    </p:spTree>
+  </p:cSld>
+  <p:clrMapOvr>
+    <a:masterClrMapping/>
+  </p:clrMapOvr>
+</p:sld>
+</file>
+
+<file path=ppt/slides/slide8.xml><?xml version="1.0" encoding="utf-8"?>
+<p:sld xmlns:a="http://schemas.openxmlformats.org/drawingml/2006/main" xmlns:r="http://schemas.openxmlformats.org/officeDocument/2006/relationships" xmlns:p="http://schemas.openxmlformats.org/presentationml/2006/main">
+  <p:cSld name="Slide 8">
     <p:bg>
       <p:bgPr>
         <a:solidFill>

</xml_diff>

<commit_message>
Add resource links slide to EGR 440 deck
Co-Authored-By: Claude Opus 5.5 <noreply@anthropic.com>
Claude-Session: https://claude.ai/code/session_016nqxio3FFGLZJDKc7yTVy5
</commit_message>
<xml_diff>
--- a/slides/EGR_440_Scalable_Innovation.pptx
+++ b/slides/EGR_440_Scalable_Innovation.pptx
@@ -14,9 +14,10 @@
     <p:sldId id="262" r:id="rId8"/>
     <p:sldId id="263" r:id="rId9"/>
     <p:sldId id="264" r:id="rId10"/>
+    <p:sldId id="265" r:id="rId11"/>
   </p:sldIdLst>
   <p:notesMasterIdLst>
-    <p:notesMasterId r:id="rId11"/>
+    <p:notesMasterId r:id="rId12"/>
   </p:notesMasterIdLst>
   <p:sldSz cx="12192000" cy="6858000"/>
   <p:notesSz cx="6858000" cy="12192000"/>
@@ -534,6 +535,94 @@
             <a:fld id="{F7021451-1387-4CA6-816F-3879F97B5CBC}" type="slidenum">
               <a:rPr lang="en-US"/>
               <a:t>1</a:t>
+            </a:fld>
+            <a:endParaRPr lang="en-US"/>
+          </a:p>
+        </p:txBody>
+      </p:sp>
+    </p:spTree>
+    <p:extLst>
+      <p:ext uri="{BB962C8B-B14F-4D97-AF65-F5344CB8AC3E}">
+        <p14:creationId xmlns:p14="http://schemas.microsoft.com/office/powerpoint/2010/main" val="1024086991"/>
+      </p:ext>
+    </p:extLst>
+  </p:cSld>
+  <p:clrMapOvr>
+    <a:masterClrMapping/>
+  </p:clrMapOvr>
+</p:notes>
+</file>
+
+<file path=ppt/notesSlides/notesSlide10.xml><?xml version="1.0" encoding="utf-8"?>
+<p:notes xmlns:a="http://schemas.openxmlformats.org/drawingml/2006/main" xmlns:r="http://schemas.openxmlformats.org/officeDocument/2006/relationships" xmlns:p="http://schemas.openxmlformats.org/presentationml/2006/main">
+  <p:cSld>
+    <p:spTree>
+      <p:nvGrpSpPr>
+        <p:cNvPr id="1" name=""/>
+        <p:cNvGrpSpPr/>
+        <p:nvPr/>
+      </p:nvGrpSpPr>
+      <p:grpSpPr>
+        <a:xfrm>
+          <a:off x="0" y="0"/>
+          <a:ext cx="0" cy="0"/>
+          <a:chOff x="0" y="0"/>
+          <a:chExt cx="0" cy="0"/>
+        </a:xfrm>
+      </p:grpSpPr>
+      <p:sp>
+        <p:nvSpPr>
+          <p:cNvPr id="2" name="Slide Image Placeholder 1"/>
+          <p:cNvSpPr>
+            <a:spLocks noGrp="1" noRot="1" noChangeAspect="1"/>
+          </p:cNvSpPr>
+          <p:nvPr>
+            <p:ph type="sldImg"/>
+          </p:nvPr>
+        </p:nvSpPr>
+        <p:spPr/>
+      </p:sp>
+      <p:sp>
+        <p:nvSpPr>
+          <p:cNvPr id="3" name="Notes Placeholder 2"/>
+          <p:cNvSpPr>
+            <a:spLocks noGrp="1"/>
+          </p:cNvSpPr>
+          <p:nvPr>
+            <p:ph type="body" idx="1"/>
+          </p:nvPr>
+        </p:nvSpPr>
+        <p:spPr/>
+        <p:txBody>
+          <a:bodyPr/>
+          <a:lstStyle/>
+          <a:p>
+            <a:r>
+              <a:rPr lang="en-US" dirty="0"/>
+              <a:t/>
+            </a:r>
+            <a:endParaRPr lang="en-US" dirty="0"/>
+          </a:p>
+        </p:txBody>
+      </p:sp>
+      <p:sp>
+        <p:nvSpPr>
+          <p:cNvPr id="4" name="Slide Number Placeholder 3"/>
+          <p:cNvSpPr>
+            <a:spLocks noGrp="1"/>
+          </p:cNvSpPr>
+          <p:nvPr>
+            <p:ph type="sldNum" sz="quarter" idx="10"/>
+          </p:nvPr>
+        </p:nvSpPr>
+        <p:spPr/>
+        <p:txBody>
+          <a:bodyPr/>
+          <a:lstStyle/>
+          <a:p>
+            <a:fld id="{F7021451-1387-4CA6-816F-3879F97B5CBC}" type="slidenum">
+              <a:rPr lang="en-US"/>
+              <a:t>10</a:t>
             </a:fld>
             <a:endParaRPr lang="en-US"/>
           </a:p>
@@ -1712,6 +1801,261 @@
 </p:sld>
 </file>
 
+<file path=ppt/slides/slide10.xml><?xml version="1.0" encoding="utf-8"?>
+<p:sld xmlns:a="http://schemas.openxmlformats.org/drawingml/2006/main" xmlns:r="http://schemas.openxmlformats.org/officeDocument/2006/relationships" xmlns:p="http://schemas.openxmlformats.org/presentationml/2006/main">
+  <p:cSld name="Slide 10">
+    <p:bg>
+      <p:bgPr>
+        <a:solidFill>
+          <a:srgbClr val="1E293B"/>
+        </a:solidFill>
+      </p:bgPr>
+    </p:bg>
+    <p:spTree>
+      <p:nvGrpSpPr>
+        <p:cNvPr id="1" name=""/>
+        <p:cNvGrpSpPr/>
+        <p:nvPr/>
+      </p:nvGrpSpPr>
+      <p:grpSpPr>
+        <a:xfrm>
+          <a:off x="0" y="0"/>
+          <a:ext cx="0" cy="0"/>
+          <a:chOff x="0" y="0"/>
+          <a:chExt cx="0" cy="0"/>
+        </a:xfrm>
+      </p:grpSpPr>
+      <p:sp>
+        <p:nvSpPr>
+          <p:cNvPr id="2" name="Text 0"/>
+          <p:cNvSpPr/>
+          <p:nvPr/>
+        </p:nvSpPr>
+        <p:spPr>
+          <a:xfrm>
+            <a:off x="731520" y="1645920"/>
+            <a:ext cx="10515600" cy="365760"/>
+          </a:xfrm>
+          <a:prstGeom prst="rect">
+            <a:avLst/>
+          </a:prstGeom>
+          <a:noFill/>
+          <a:ln/>
+        </p:spPr>
+        <p:txBody>
+          <a:bodyPr wrap="square" rtlCol="0" anchor="ctr"/>
+          <a:lstStyle/>
+          <a:p>
+            <a:pPr algn="ctr" indent="0" marL="0">
+              <a:buNone/>
+            </a:pPr>
+            <a:r>
+              <a:rPr lang="en-US" sz="1200" b="1" spc="200" kern="0" dirty="0">
+                <a:solidFill>
+                  <a:srgbClr val="F59E0B"/>
+                </a:solidFill>
+                <a:latin typeface="Calibri" pitchFamily="34" charset="0"/>
+                <a:ea typeface="Calibri" pitchFamily="34" charset="-122"/>
+                <a:cs typeface="Calibri" pitchFamily="34" charset="-120"/>
+              </a:rPr>
+              <a:t>10 MINUTES OF DATA VS. 6 MONTHS IN THE LAB</a:t>
+            </a:r>
+            <a:endParaRPr lang="en-US" sz="1200" dirty="0"/>
+          </a:p>
+        </p:txBody>
+      </p:sp>
+      <p:sp>
+        <p:nvSpPr>
+          <p:cNvPr id="3" name="Text 1"/>
+          <p:cNvSpPr/>
+          <p:nvPr/>
+        </p:nvSpPr>
+        <p:spPr>
+          <a:xfrm>
+            <a:off x="914400" y="2194560"/>
+            <a:ext cx="10332720" cy="1828800"/>
+          </a:xfrm>
+          <a:prstGeom prst="rect">
+            <a:avLst/>
+          </a:prstGeom>
+          <a:noFill/>
+          <a:ln/>
+        </p:spPr>
+        <p:txBody>
+          <a:bodyPr wrap="square" rtlCol="0" anchor="ctr"/>
+          <a:lstStyle/>
+          <a:p>
+            <a:pPr algn="ctr" indent="0" marL="0">
+              <a:lnSpc>
+                <a:spcPts val="4200"/>
+              </a:lnSpc>
+              <a:buNone/>
+            </a:pPr>
+            <a:r>
+              <a:rPr lang="en-US" sz="3200" b="1" dirty="0">
+                <a:solidFill>
+                  <a:srgbClr val="F8FAFC"/>
+                </a:solidFill>
+                <a:latin typeface="Calibri" pitchFamily="34" charset="0"/>
+                <a:ea typeface="Calibri" pitchFamily="34" charset="-122"/>
+                <a:cs typeface="Calibri" pitchFamily="34" charset="-120"/>
+              </a:rPr>
+              <a:t>"10 minutes of database triangulation prevents 6 months of building the wrong physical prototype."</a:t>
+            </a:r>
+            <a:endParaRPr lang="en-US" sz="3200" dirty="0"/>
+          </a:p>
+        </p:txBody>
+      </p:sp>
+      <p:sp>
+        <p:nvSpPr>
+          <p:cNvPr id="4" name="Text 2"/>
+          <p:cNvSpPr/>
+          <p:nvPr/>
+        </p:nvSpPr>
+        <p:spPr>
+          <a:xfrm>
+            <a:off x="731520" y="4206240"/>
+            <a:ext cx="10515600" cy="457200"/>
+          </a:xfrm>
+          <a:prstGeom prst="rect">
+            <a:avLst/>
+          </a:prstGeom>
+          <a:noFill/>
+          <a:ln/>
+        </p:spPr>
+        <p:txBody>
+          <a:bodyPr wrap="square" rtlCol="0" anchor="ctr"/>
+          <a:lstStyle/>
+          <a:p>
+            <a:pPr algn="ctr" indent="0" marL="0">
+              <a:buNone/>
+            </a:pPr>
+            <a:r>
+              <a:rPr lang="en-US" sz="2000" b="1" dirty="0">
+                <a:solidFill>
+                  <a:srgbClr val="38BDF8"/>
+                </a:solidFill>
+                <a:latin typeface="Calibri" pitchFamily="34" charset="0"/>
+                <a:ea typeface="Calibri" pitchFamily="34" charset="-122"/>
+                <a:cs typeface="Calibri" pitchFamily="34" charset="-120"/>
+              </a:rPr>
+              <a:t>Engineer the business model before you solder the board.</a:t>
+            </a:r>
+            <a:endParaRPr lang="en-US" sz="2000" dirty="0"/>
+          </a:p>
+        </p:txBody>
+      </p:sp>
+      <p:sp>
+        <p:nvSpPr>
+          <p:cNvPr id="5" name="Shape 3"/>
+          <p:cNvSpPr/>
+          <p:nvPr/>
+        </p:nvSpPr>
+        <p:spPr>
+          <a:xfrm>
+            <a:off x="3017520" y="5029200"/>
+            <a:ext cx="6126480" cy="1097280"/>
+          </a:xfrm>
+          <a:prstGeom prst="rect">
+            <a:avLst/>
+          </a:prstGeom>
+          <a:solidFill>
+            <a:srgbClr val="334155"/>
+          </a:solidFill>
+          <a:ln w="12700">
+            <a:solidFill>
+              <a:srgbClr val="475569"/>
+            </a:solidFill>
+            <a:prstDash val="solid"/>
+          </a:ln>
+        </p:spPr>
+      </p:sp>
+      <p:sp>
+        <p:nvSpPr>
+          <p:cNvPr id="6" name="Text 4"/>
+          <p:cNvSpPr/>
+          <p:nvPr/>
+        </p:nvSpPr>
+        <p:spPr>
+          <a:xfrm>
+            <a:off x="3017520" y="5212080"/>
+            <a:ext cx="6126480" cy="274320"/>
+          </a:xfrm>
+          <a:prstGeom prst="rect">
+            <a:avLst/>
+          </a:prstGeom>
+          <a:noFill/>
+          <a:ln/>
+        </p:spPr>
+        <p:txBody>
+          <a:bodyPr wrap="square" rtlCol="0" anchor="ctr"/>
+          <a:lstStyle/>
+          <a:p>
+            <a:pPr algn="ctr" indent="0" marL="0">
+              <a:buNone/>
+            </a:pPr>
+            <a:r>
+              <a:rPr lang="en-US" sz="1300" b="1" dirty="0">
+                <a:solidFill>
+                  <a:srgbClr val="F8FAFC"/>
+                </a:solidFill>
+                <a:latin typeface="Calibri" pitchFamily="34" charset="0"/>
+                <a:ea typeface="Calibri" pitchFamily="34" charset="-122"/>
+                <a:cs typeface="Calibri" pitchFamily="34" charset="-120"/>
+              </a:rPr>
+              <a:t>Terence O'Neill | Entrepreneurship Librarian</a:t>
+            </a:r>
+            <a:endParaRPr lang="en-US" sz="1300" dirty="0"/>
+          </a:p>
+        </p:txBody>
+      </p:sp>
+      <p:sp>
+        <p:nvSpPr>
+          <p:cNvPr id="7" name="Text 5"/>
+          <p:cNvSpPr/>
+          <p:nvPr/>
+        </p:nvSpPr>
+        <p:spPr>
+          <a:xfrm>
+            <a:off x="3017520" y="5577840"/>
+            <a:ext cx="6126480" cy="274320"/>
+          </a:xfrm>
+          <a:prstGeom prst="rect">
+            <a:avLst/>
+          </a:prstGeom>
+          <a:noFill/>
+          <a:ln/>
+        </p:spPr>
+        <p:txBody>
+          <a:bodyPr wrap="square" rtlCol="0" anchor="ctr"/>
+          <a:lstStyle/>
+          <a:p>
+            <a:pPr algn="ctr" indent="0" marL="0">
+              <a:buNone/>
+            </a:pPr>
+            <a:r>
+              <a:rPr lang="en-US" sz="1200" dirty="0">
+                <a:solidFill>
+                  <a:srgbClr val="38BDF8"/>
+                </a:solidFill>
+                <a:latin typeface="Calibri" pitchFamily="34" charset="0"/>
+                <a:ea typeface="Calibri" pitchFamily="34" charset="-122"/>
+                <a:cs typeface="Calibri" pitchFamily="34" charset="-120"/>
+              </a:rPr>
+              <a:t>MSU Libraries Hub: libguides.lib.msu.edu/entrepreneur</a:t>
+            </a:r>
+            <a:endParaRPr lang="en-US" sz="1200" dirty="0"/>
+          </a:p>
+        </p:txBody>
+      </p:sp>
+    </p:spTree>
+  </p:cSld>
+  <p:clrMapOvr>
+    <a:masterClrMapping/>
+  </p:clrMapOvr>
+</p:sld>
+</file>
+
 <file path=ppt/slides/slide2.xml><?xml version="1.0" encoding="utf-8"?>
 <p:sld xmlns:a="http://schemas.openxmlformats.org/drawingml/2006/main" xmlns:r="http://schemas.openxmlformats.org/officeDocument/2006/relationships" xmlns:p="http://schemas.openxmlformats.org/presentationml/2006/main">
   <p:cSld name="Slide 2">
@@ -6348,34 +6692,34 @@
         </p:nvSpPr>
         <p:spPr>
           <a:xfrm>
-            <a:off x="731520" y="1645920"/>
-            <a:ext cx="10515600" cy="365760"/>
-          </a:xfrm>
-          <a:prstGeom prst="rect">
-            <a:avLst/>
-          </a:prstGeom>
-          <a:noFill/>
-          <a:ln/>
-        </p:spPr>
-        <p:txBody>
-          <a:bodyPr wrap="square" rtlCol="0" anchor="ctr"/>
-          <a:lstStyle/>
-          <a:p>
-            <a:pPr algn="ctr" indent="0" marL="0">
-              <a:buNone/>
-            </a:pPr>
-            <a:r>
-              <a:rPr lang="en-US" sz="1200" b="1" spc="200" kern="0" dirty="0">
-                <a:solidFill>
-                  <a:srgbClr val="F59E0B"/>
-                </a:solidFill>
-                <a:latin typeface="Calibri" pitchFamily="34" charset="0"/>
-                <a:ea typeface="Calibri" pitchFamily="34" charset="-122"/>
-                <a:cs typeface="Calibri" pitchFamily="34" charset="-120"/>
-              </a:rPr>
-              <a:t>10 MINUTES OF DATA VS. 6 MONTHS IN THE LAB</a:t>
-            </a:r>
-            <a:endParaRPr lang="en-US" sz="1200" dirty="0"/>
+            <a:off x="731520" y="457200"/>
+            <a:ext cx="10515600" cy="274320"/>
+          </a:xfrm>
+          <a:prstGeom prst="rect">
+            <a:avLst/>
+          </a:prstGeom>
+          <a:noFill/>
+          <a:ln/>
+        </p:spPr>
+        <p:txBody>
+          <a:bodyPr wrap="square" rtlCol="0" anchor="ctr"/>
+          <a:lstStyle/>
+          <a:p>
+            <a:pPr indent="0" marL="0">
+              <a:buNone/>
+            </a:pPr>
+            <a:r>
+              <a:rPr lang="en-US" sz="1100" b="1" spc="150" kern="0" dirty="0">
+                <a:solidFill>
+                  <a:srgbClr val="38BDF8"/>
+                </a:solidFill>
+                <a:latin typeface="Calibri" pitchFamily="34" charset="0"/>
+                <a:ea typeface="Calibri" pitchFamily="34" charset="-122"/>
+                <a:cs typeface="Calibri" pitchFamily="34" charset="-120"/>
+              </a:rPr>
+              <a:t>RESOURCES</a:t>
+            </a:r>
+            <a:endParaRPr lang="en-US" sz="1100" dirty="0"/>
           </a:p>
         </p:txBody>
       </p:sp>
@@ -6387,27 +6731,24 @@
         </p:nvSpPr>
         <p:spPr>
           <a:xfrm>
-            <a:off x="914400" y="2194560"/>
-            <a:ext cx="10332720" cy="1828800"/>
-          </a:xfrm>
-          <a:prstGeom prst="rect">
-            <a:avLst/>
-          </a:prstGeom>
-          <a:noFill/>
-          <a:ln/>
-        </p:spPr>
-        <p:txBody>
-          <a:bodyPr wrap="square" rtlCol="0" anchor="ctr"/>
-          <a:lstStyle/>
-          <a:p>
-            <a:pPr algn="ctr" indent="0" marL="0">
-              <a:lnSpc>
-                <a:spcPts val="4200"/>
-              </a:lnSpc>
-              <a:buNone/>
-            </a:pPr>
-            <a:r>
-              <a:rPr lang="en-US" sz="3200" b="1" dirty="0">
+            <a:off x="731520" y="731520"/>
+            <a:ext cx="10515600" cy="548640"/>
+          </a:xfrm>
+          <a:prstGeom prst="rect">
+            <a:avLst/>
+          </a:prstGeom>
+          <a:noFill/>
+          <a:ln/>
+        </p:spPr>
+        <p:txBody>
+          <a:bodyPr wrap="square" rtlCol="0" anchor="ctr"/>
+          <a:lstStyle/>
+          <a:p>
+            <a:pPr indent="0" marL="0">
+              <a:buNone/>
+            </a:pPr>
+            <a:r>
+              <a:rPr lang="en-US" sz="2600" b="1" dirty="0">
                 <a:solidFill>
                   <a:srgbClr val="F8FAFC"/>
                 </a:solidFill>
@@ -6415,61 +6756,22 @@
                 <a:ea typeface="Calibri" pitchFamily="34" charset="-122"/>
                 <a:cs typeface="Calibri" pitchFamily="34" charset="-120"/>
               </a:rPr>
-              <a:t>"10 minutes of database triangulation prevents 6 months of building the wrong physical prototype."</a:t>
-            </a:r>
-            <a:endParaRPr lang="en-US" sz="3200" dirty="0"/>
-          </a:p>
-        </p:txBody>
-      </p:sp>
-      <p:sp>
-        <p:nvSpPr>
-          <p:cNvPr id="4" name="Text 2"/>
-          <p:cNvSpPr/>
-          <p:nvPr/>
-        </p:nvSpPr>
-        <p:spPr>
-          <a:xfrm>
-            <a:off x="731520" y="4206240"/>
-            <a:ext cx="10515600" cy="457200"/>
-          </a:xfrm>
-          <a:prstGeom prst="rect">
-            <a:avLst/>
-          </a:prstGeom>
-          <a:noFill/>
-          <a:ln/>
-        </p:spPr>
-        <p:txBody>
-          <a:bodyPr wrap="square" rtlCol="0" anchor="ctr"/>
-          <a:lstStyle/>
-          <a:p>
-            <a:pPr algn="ctr" indent="0" marL="0">
-              <a:buNone/>
-            </a:pPr>
-            <a:r>
-              <a:rPr lang="en-US" sz="2000" b="1" dirty="0">
-                <a:solidFill>
-                  <a:srgbClr val="38BDF8"/>
-                </a:solidFill>
-                <a:latin typeface="Calibri" pitchFamily="34" charset="0"/>
-                <a:ea typeface="Calibri" pitchFamily="34" charset="-122"/>
-                <a:cs typeface="Calibri" pitchFamily="34" charset="-120"/>
-              </a:rPr>
-              <a:t>Engineer the business model before you solder the board.</a:t>
-            </a:r>
-            <a:endParaRPr lang="en-US" sz="2000" dirty="0"/>
-          </a:p>
-        </p:txBody>
-      </p:sp>
-      <p:sp>
-        <p:nvSpPr>
-          <p:cNvPr id="5" name="Shape 3"/>
-          <p:cNvSpPr/>
-          <p:nvPr/>
-        </p:nvSpPr>
-        <p:spPr>
-          <a:xfrm>
-            <a:off x="3017520" y="5029200"/>
-            <a:ext cx="6126480" cy="1097280"/>
+              <a:t>Keep Going: Library Resources</a:t>
+            </a:r>
+            <a:endParaRPr lang="en-US" sz="2600" dirty="0"/>
+          </a:p>
+        </p:txBody>
+      </p:sp>
+      <p:sp>
+        <p:nvSpPr>
+          <p:cNvPr id="4" name="Shape 2"/>
+          <p:cNvSpPr/>
+          <p:nvPr/>
+        </p:nvSpPr>
+        <p:spPr>
+          <a:xfrm>
+            <a:off x="731520" y="1828800"/>
+            <a:ext cx="5212080" cy="3108960"/>
           </a:xfrm>
           <a:prstGeom prst="rect">
             <a:avLst/>
@@ -6477,9 +6779,9 @@
           <a:solidFill>
             <a:srgbClr val="334155"/>
           </a:solidFill>
-          <a:ln w="12700">
+          <a:ln w="19050">
             <a:solidFill>
-              <a:srgbClr val="475569"/>
+              <a:srgbClr val="38BDF8"/>
             </a:solidFill>
             <a:prstDash val="solid"/>
           </a:ln>
@@ -6487,30 +6789,69 @@
       </p:sp>
       <p:sp>
         <p:nvSpPr>
+          <p:cNvPr id="5" name="Text 3"/>
+          <p:cNvSpPr/>
+          <p:nvPr/>
+        </p:nvSpPr>
+        <p:spPr>
+          <a:xfrm>
+            <a:off x="1097280" y="2194560"/>
+            <a:ext cx="4480560" cy="365760"/>
+          </a:xfrm>
+          <a:prstGeom prst="rect">
+            <a:avLst/>
+          </a:prstGeom>
+          <a:noFill/>
+          <a:ln/>
+        </p:spPr>
+        <p:txBody>
+          <a:bodyPr wrap="square" rtlCol="0" anchor="ctr"/>
+          <a:lstStyle/>
+          <a:p>
+            <a:pPr indent="0" marL="0">
+              <a:buNone/>
+            </a:pPr>
+            <a:r>
+              <a:rPr lang="en-US" sz="1800" b="1" dirty="0">
+                <a:solidFill>
+                  <a:srgbClr val="38BDF8"/>
+                </a:solidFill>
+                <a:latin typeface="Calibri" pitchFamily="34" charset="0"/>
+                <a:ea typeface="Calibri" pitchFamily="34" charset="-122"/>
+                <a:cs typeface="Calibri" pitchFamily="34" charset="-120"/>
+              </a:rPr>
+              <a:t>ENTREPRENEURSHIP RESEARCH GUIDE</a:t>
+            </a:r>
+            <a:endParaRPr lang="en-US" sz="1800" dirty="0"/>
+          </a:p>
+        </p:txBody>
+      </p:sp>
+      <p:sp>
+        <p:nvSpPr>
           <p:cNvPr id="6" name="Text 4"/>
           <p:cNvSpPr/>
           <p:nvPr/>
         </p:nvSpPr>
         <p:spPr>
           <a:xfrm>
-            <a:off x="3017520" y="5212080"/>
-            <a:ext cx="6126480" cy="274320"/>
-          </a:xfrm>
-          <a:prstGeom prst="rect">
-            <a:avLst/>
-          </a:prstGeom>
-          <a:noFill/>
-          <a:ln/>
-        </p:spPr>
-        <p:txBody>
-          <a:bodyPr wrap="square" rtlCol="0" anchor="ctr"/>
-          <a:lstStyle/>
-          <a:p>
-            <a:pPr algn="ctr" indent="0" marL="0">
-              <a:buNone/>
-            </a:pPr>
-            <a:r>
-              <a:rPr lang="en-US" sz="1300" b="1" dirty="0">
+            <a:off x="1097280" y="2743200"/>
+            <a:ext cx="4480560" cy="914400"/>
+          </a:xfrm>
+          <a:prstGeom prst="rect">
+            <a:avLst/>
+          </a:prstGeom>
+          <a:noFill/>
+          <a:ln/>
+        </p:spPr>
+        <p:txBody>
+          <a:bodyPr wrap="square" rtlCol="0" anchor="t"/>
+          <a:lstStyle/>
+          <a:p>
+            <a:pPr indent="0" marL="0">
+              <a:buNone/>
+            </a:pPr>
+            <a:r>
+              <a:rPr lang="en-US" sz="1500" dirty="0">
                 <a:solidFill>
                   <a:srgbClr val="F8FAFC"/>
                 </a:solidFill>
@@ -6518,9 +6859,9 @@
                 <a:ea typeface="Calibri" pitchFamily="34" charset="-122"/>
                 <a:cs typeface="Calibri" pitchFamily="34" charset="-120"/>
               </a:rPr>
-              <a:t>Terence O'Neill | Entrepreneurship Librarian</a:t>
-            </a:r>
-            <a:endParaRPr lang="en-US" sz="1300" dirty="0"/>
+              <a:t>Databases, search tips, and help for market and industry research.</a:t>
+            </a:r>
+            <a:endParaRPr lang="en-US" sz="1500" dirty="0"/>
           </a:p>
         </p:txBody>
       </p:sp>
@@ -6532,34 +6873,229 @@
         </p:nvSpPr>
         <p:spPr>
           <a:xfrm>
-            <a:off x="3017520" y="5577840"/>
-            <a:ext cx="6126480" cy="274320"/>
-          </a:xfrm>
-          <a:prstGeom prst="rect">
-            <a:avLst/>
-          </a:prstGeom>
-          <a:noFill/>
-          <a:ln/>
-        </p:spPr>
-        <p:txBody>
-          <a:bodyPr wrap="square" rtlCol="0" anchor="ctr"/>
-          <a:lstStyle/>
-          <a:p>
-            <a:pPr algn="ctr" indent="0" marL="0">
-              <a:buNone/>
-            </a:pPr>
-            <a:r>
-              <a:rPr lang="en-US" sz="1200" dirty="0">
-                <a:solidFill>
-                  <a:srgbClr val="38BDF8"/>
-                </a:solidFill>
-                <a:latin typeface="Calibri" pitchFamily="34" charset="0"/>
-                <a:ea typeface="Calibri" pitchFamily="34" charset="-122"/>
-                <a:cs typeface="Calibri" pitchFamily="34" charset="-120"/>
-              </a:rPr>
-              <a:t>MSU Libraries Hub: libguides.lib.msu.edu/entrepreneur</a:t>
-            </a:r>
-            <a:endParaRPr lang="en-US" sz="1200" dirty="0"/>
+            <a:off x="1097280" y="4023360"/>
+            <a:ext cx="4480560" cy="457200"/>
+          </a:xfrm>
+          <a:prstGeom prst="rect">
+            <a:avLst/>
+          </a:prstGeom>
+          <a:noFill/>
+          <a:ln/>
+        </p:spPr>
+        <p:txBody>
+          <a:bodyPr wrap="square" rtlCol="0" anchor="ctr"/>
+          <a:lstStyle/>
+          <a:p>
+            <a:pPr indent="0" marL="0">
+              <a:buNone/>
+            </a:pPr>
+            <a:r>
+              <a:rPr lang="en-US" sz="1600" b="1" u="sng" dirty="0">
+                <a:solidFill>
+                  <a:srgbClr val="F8FAFC"/>
+                </a:solidFill>
+                <a:latin typeface="Calibri" pitchFamily="34" charset="0"/>
+                <a:ea typeface="Calibri" pitchFamily="34" charset="-122"/>
+                <a:cs typeface="Calibri" pitchFamily="34" charset="-120"/>
+                <a:hlinkClick r:id="rId1" invalidUrl="" action="" tgtFrame="" tooltip="https://libguides.lib.msu.edu/entrepreneur" history="1" highlightClick="0" endSnd="0">
+                  <a:extLst>
+                    <a:ext uri="{A12FA001-AC4F-418D-AE19-62706E023703}">
+                      <ahyp:hlinkClr xmlns:ahyp="http://schemas.microsoft.com/office/drawing/2018/hyperlinkcolor" val="tx"/>
+                    </a:ext>
+                  </a:extLst>
+                </a:hlinkClick>
+              </a:rPr>
+              <a:t>libguides.lib.msu.edu/entrepreneur</a:t>
+            </a:r>
+            <a:endParaRPr lang="en-US" sz="1600" dirty="0"/>
+          </a:p>
+        </p:txBody>
+      </p:sp>
+      <p:sp>
+        <p:nvSpPr>
+          <p:cNvPr id="8" name="Shape 6"/>
+          <p:cNvSpPr/>
+          <p:nvPr/>
+        </p:nvSpPr>
+        <p:spPr>
+          <a:xfrm>
+            <a:off x="6217920" y="1828800"/>
+            <a:ext cx="5212080" cy="3108960"/>
+          </a:xfrm>
+          <a:prstGeom prst="rect">
+            <a:avLst/>
+          </a:prstGeom>
+          <a:solidFill>
+            <a:srgbClr val="334155"/>
+          </a:solidFill>
+          <a:ln w="19050">
+            <a:solidFill>
+              <a:srgbClr val="F59E0B"/>
+            </a:solidFill>
+            <a:prstDash val="solid"/>
+          </a:ln>
+        </p:spPr>
+      </p:sp>
+      <p:sp>
+        <p:nvSpPr>
+          <p:cNvPr id="9" name="Text 7"/>
+          <p:cNvSpPr/>
+          <p:nvPr/>
+        </p:nvSpPr>
+        <p:spPr>
+          <a:xfrm>
+            <a:off x="6583680" y="2194560"/>
+            <a:ext cx="4480560" cy="365760"/>
+          </a:xfrm>
+          <a:prstGeom prst="rect">
+            <a:avLst/>
+          </a:prstGeom>
+          <a:noFill/>
+          <a:ln/>
+        </p:spPr>
+        <p:txBody>
+          <a:bodyPr wrap="square" rtlCol="0" anchor="ctr"/>
+          <a:lstStyle/>
+          <a:p>
+            <a:pPr indent="0" marL="0">
+              <a:buNone/>
+            </a:pPr>
+            <a:r>
+              <a:rPr lang="en-US" sz="1800" b="1" dirty="0">
+                <a:solidFill>
+                  <a:srgbClr val="F59E0B"/>
+                </a:solidFill>
+                <a:latin typeface="Calibri" pitchFamily="34" charset="0"/>
+                <a:ea typeface="Calibri" pitchFamily="34" charset="-122"/>
+                <a:cs typeface="Calibri" pitchFamily="34" charset="-120"/>
+              </a:rPr>
+              <a:t>MSU LIBRARIES MAKERSPACE</a:t>
+            </a:r>
+            <a:endParaRPr lang="en-US" sz="1800" dirty="0"/>
+          </a:p>
+        </p:txBody>
+      </p:sp>
+      <p:sp>
+        <p:nvSpPr>
+          <p:cNvPr id="10" name="Text 8"/>
+          <p:cNvSpPr/>
+          <p:nvPr/>
+        </p:nvSpPr>
+        <p:spPr>
+          <a:xfrm>
+            <a:off x="6583680" y="2743200"/>
+            <a:ext cx="4480560" cy="914400"/>
+          </a:xfrm>
+          <a:prstGeom prst="rect">
+            <a:avLst/>
+          </a:prstGeom>
+          <a:noFill/>
+          <a:ln/>
+        </p:spPr>
+        <p:txBody>
+          <a:bodyPr wrap="square" rtlCol="0" anchor="t"/>
+          <a:lstStyle/>
+          <a:p>
+            <a:pPr indent="0" marL="0">
+              <a:buNone/>
+            </a:pPr>
+            <a:r>
+              <a:rPr lang="en-US" sz="1500" dirty="0">
+                <a:solidFill>
+                  <a:srgbClr val="F8FAFC"/>
+                </a:solidFill>
+                <a:latin typeface="Calibri" pitchFamily="34" charset="0"/>
+                <a:ea typeface="Calibri" pitchFamily="34" charset="-122"/>
+                <a:cs typeface="Calibri" pitchFamily="34" charset="-120"/>
+              </a:rPr>
+              <a:t>Equipment and support for building and testing your prototype.</a:t>
+            </a:r>
+            <a:endParaRPr lang="en-US" sz="1500" dirty="0"/>
+          </a:p>
+        </p:txBody>
+      </p:sp>
+      <p:sp>
+        <p:nvSpPr>
+          <p:cNvPr id="11" name="Text 9"/>
+          <p:cNvSpPr/>
+          <p:nvPr/>
+        </p:nvSpPr>
+        <p:spPr>
+          <a:xfrm>
+            <a:off x="6583680" y="4023360"/>
+            <a:ext cx="4480560" cy="457200"/>
+          </a:xfrm>
+          <a:prstGeom prst="rect">
+            <a:avLst/>
+          </a:prstGeom>
+          <a:noFill/>
+          <a:ln/>
+        </p:spPr>
+        <p:txBody>
+          <a:bodyPr wrap="square" rtlCol="0" anchor="ctr"/>
+          <a:lstStyle/>
+          <a:p>
+            <a:pPr indent="0" marL="0">
+              <a:buNone/>
+            </a:pPr>
+            <a:r>
+              <a:rPr lang="en-US" sz="1600" b="1" u="sng" dirty="0">
+                <a:solidFill>
+                  <a:srgbClr val="F8FAFC"/>
+                </a:solidFill>
+                <a:latin typeface="Calibri" pitchFamily="34" charset="0"/>
+                <a:ea typeface="Calibri" pitchFamily="34" charset="-122"/>
+                <a:cs typeface="Calibri" pitchFamily="34" charset="-120"/>
+                <a:hlinkClick r:id="rId2" invalidUrl="" action="" tgtFrame="" tooltip="https://lib.msu.edu/makerspace" history="1" highlightClick="0" endSnd="0">
+                  <a:extLst>
+                    <a:ext uri="{A12FA001-AC4F-418D-AE19-62706E023703}">
+                      <ahyp:hlinkClr xmlns:ahyp="http://schemas.microsoft.com/office/drawing/2018/hyperlinkcolor" val="tx"/>
+                    </a:ext>
+                  </a:extLst>
+                </a:hlinkClick>
+              </a:rPr>
+              <a:t>lib.msu.edu/makerspace</a:t>
+            </a:r>
+            <a:endParaRPr lang="en-US" sz="1600" dirty="0"/>
+          </a:p>
+        </p:txBody>
+      </p:sp>
+      <p:sp>
+        <p:nvSpPr>
+          <p:cNvPr id="12" name="Text 10"/>
+          <p:cNvSpPr/>
+          <p:nvPr/>
+        </p:nvSpPr>
+        <p:spPr>
+          <a:xfrm>
+            <a:off x="731520" y="6400800"/>
+            <a:ext cx="10698480" cy="274320"/>
+          </a:xfrm>
+          <a:prstGeom prst="rect">
+            <a:avLst/>
+          </a:prstGeom>
+          <a:noFill/>
+          <a:ln/>
+        </p:spPr>
+        <p:txBody>
+          <a:bodyPr wrap="square" rtlCol="0" anchor="ctr"/>
+          <a:lstStyle/>
+          <a:p>
+            <a:pPr indent="0" marL="0">
+              <a:buNone/>
+            </a:pPr>
+            <a:r>
+              <a:rPr lang="en-US" sz="1000" dirty="0">
+                <a:solidFill>
+                  <a:srgbClr val="94A3B8"/>
+                </a:solidFill>
+                <a:latin typeface="Calibri" pitchFamily="34" charset="0"/>
+                <a:ea typeface="Calibri" pitchFamily="34" charset="-122"/>
+                <a:cs typeface="Calibri" pitchFamily="34" charset="-120"/>
+              </a:rPr>
+              <a:t>EGR 440 | MSU Libraries Entrepreneurship Hub: libguides.lib.msu.edu/entrepreneur</a:t>
+            </a:r>
+            <a:endParaRPr lang="en-US" sz="1000" dirty="0"/>
           </a:p>
         </p:txBody>
       </p:sp>

</xml_diff>